<commit_message>
Visualize cross-setting PP-X collapse resistance
Co-authored-by: Cursor <cursoragent@cursor.com>
</commit_message>
<xml_diff>
--- a/ppt/PP-X_Final_Visual_Talk_20min.pptx
+++ b/ppt/PP-X_Final_Visual_Talk_20min.pptx
@@ -21,6 +21,7 @@
     <p:sldId id="269" r:id="rId20"/>
     <p:sldId id="270" r:id="rId21"/>
     <p:sldId id="271" r:id="rId22"/>
+    <p:sldId id="272" r:id="rId23"/>
   </p:sldIdLst>
   <p:sldSz cx="12191695" cy="6858000" type="screen4x3"/>
   <p:notesSz cx="6858000" cy="9144000"/>
@@ -3421,7 +3422,7 @@
                 </a:solidFill>
                 <a:latin typeface="Apple SD Gothic Neo"/>
               </a:rPr>
-              <a:t>01 / 16</a:t>
+              <a:t>01 / 17</a:t>
             </a:r>
           </a:p>
         </p:txBody>
@@ -4989,7 +4990,7 @@
                 </a:solidFill>
                 <a:latin typeface="Apple SD Gothic Neo"/>
               </a:rPr>
-              <a:t>통계검정 — 행이 아니라 물리 unit이 표본</a:t>
+              <a:t>외삽 붕괴 비교 — 낮은 편차와 높은 최악 성능</a:t>
             </a:r>
           </a:p>
         </p:txBody>
@@ -5028,7 +5029,7 @@
                 </a:solidFill>
                 <a:latin typeface="Apple SD Gothic Neo"/>
               </a:rPr>
-              <a:t>요약 효과와 개별 component evidence를 분리한다.</a:t>
+              <a:t>점 크기 = R²&gt;0 setting 수 (9개 중)</a:t>
             </a:r>
           </a:p>
         </p:txBody>
@@ -5107,16 +5108,40 @@
           </a:fontRef>
         </p:style>
       </p:cxnSp>
-      <p:sp>
-        <p:nvSpPr>
-          <p:cNvPr id="6" name="Rounded Rectangle 5"/>
+      <p:pic>
+        <p:nvPicPr>
+          <p:cNvPr id="6" name="Picture 5" descr="stability.png"/>
+          <p:cNvPicPr>
+            <a:picLocks noChangeAspect="1"/>
+          </p:cNvPicPr>
+          <p:nvPr/>
+        </p:nvPicPr>
+        <p:blipFill>
+          <a:blip r:embed="rId2"/>
+          <a:stretch>
+            <a:fillRect/>
+          </a:stretch>
+        </p:blipFill>
+        <p:spPr>
+          <a:xfrm>
+            <a:off x="594360" y="1188720"/>
+            <a:ext cx="8549640" cy="4983480"/>
+          </a:xfrm>
+          <a:prstGeom prst="rect">
+            <a:avLst/>
+          </a:prstGeom>
+        </p:spPr>
+      </p:pic>
+      <p:sp>
+        <p:nvSpPr>
+          <p:cNvPr id="7" name="Rounded Rectangle 6"/>
           <p:cNvSpPr/>
           <p:nvPr/>
         </p:nvSpPr>
         <p:spPr>
           <a:xfrm>
-            <a:off x="685800" y="1417320"/>
-            <a:ext cx="2194560" cy="1828800"/>
+            <a:off x="9189720" y="1417320"/>
+            <a:ext cx="2331720" cy="3474720"/>
           </a:xfrm>
           <a:prstGeom prst="roundRect">
             <a:avLst/>
@@ -5154,14 +5179,14 @@
       </p:sp>
       <p:sp>
         <p:nvSpPr>
-          <p:cNvPr id="7" name="TextBox 6"/>
-          <p:cNvSpPr txBox="1"/>
-          <p:nvPr/>
-        </p:nvSpPr>
-        <p:spPr>
-          <a:xfrm>
-            <a:off x="685800" y="1664208"/>
-            <a:ext cx="2194560" cy="548640"/>
+          <p:cNvPr id="8" name="TextBox 7"/>
+          <p:cNvSpPr txBox="1"/>
+          <p:nvPr/>
+        </p:nvSpPr>
+        <p:spPr>
+          <a:xfrm>
+            <a:off x="9418320" y="1691640"/>
+            <a:ext cx="1874519" cy="411480"/>
           </a:xfrm>
           <a:prstGeom prst="rect">
             <a:avLst/>
@@ -5180,27 +5205,27 @@
               </a:spcAft>
             </a:pPr>
             <a:r>
-              <a:rPr sz="2200" b="1">
+              <a:rPr sz="2100" b="1">
                 <a:solidFill>
                   <a:srgbClr val="1F6BB5"/>
                 </a:solidFill>
                 <a:latin typeface="Apple SD Gothic Neo"/>
               </a:rPr>
-              <a:t>9 / 9</a:t>
-            </a:r>
-          </a:p>
-        </p:txBody>
-      </p:sp>
-      <p:sp>
-        <p:nvSpPr>
-          <p:cNvPr id="8" name="TextBox 7"/>
-          <p:cNvSpPr txBox="1"/>
-          <p:nvPr/>
-        </p:nvSpPr>
-        <p:spPr>
-          <a:xfrm>
-            <a:off x="685800" y="2359152"/>
-            <a:ext cx="2194560" cy="594360"/>
+              <a:t>PP-X</a:t>
+            </a:r>
+          </a:p>
+        </p:txBody>
+      </p:sp>
+      <p:sp>
+        <p:nvSpPr>
+          <p:cNvPr id="9" name="TextBox 8"/>
+          <p:cNvSpPr txBox="1"/>
+          <p:nvPr/>
+        </p:nvSpPr>
+        <p:spPr>
+          <a:xfrm>
+            <a:off x="9418320" y="2395728"/>
+            <a:ext cx="1874519" cy="1508760"/>
           </a:xfrm>
           <a:prstGeom prst="rect">
             <a:avLst/>
@@ -5219,474 +5244,30 @@
               </a:spcAft>
             </a:pPr>
             <a:r>
-              <a:rPr sz="1150" b="1">
+              <a:rPr sz="1500" b="1">
                 <a:solidFill>
                   <a:srgbClr val="1A232F"/>
                 </a:solidFill>
                 <a:latin typeface="Apple SD Gothic Neo"/>
               </a:rPr>
-              <a:t>vs matched direct
-방향 일치</a:t>
-            </a:r>
-          </a:p>
-        </p:txBody>
-      </p:sp>
-      <p:sp>
-        <p:nvSpPr>
-          <p:cNvPr id="9" name="Rounded Rectangle 8"/>
+              <a:t>domain SD
+0.174
+worst R²
+0.466</a:t>
+            </a:r>
+          </a:p>
+        </p:txBody>
+      </p:sp>
+      <p:sp>
+        <p:nvSpPr>
+          <p:cNvPr id="10" name="Rounded Rectangle 9"/>
           <p:cNvSpPr/>
           <p:nvPr/>
         </p:nvSpPr>
         <p:spPr>
           <a:xfrm>
-            <a:off x="3566160" y="1417320"/>
-            <a:ext cx="2194560" cy="1828800"/>
-          </a:xfrm>
-          <a:prstGeom prst="roundRect">
-            <a:avLst/>
-          </a:prstGeom>
-          <a:solidFill>
-            <a:srgbClr val="E6F7F9"/>
-          </a:solidFill>
-          <a:ln w="15240">
-            <a:solidFill>
-              <a:srgbClr val="2D9DB8"/>
-            </a:solidFill>
-          </a:ln>
-        </p:spPr>
-        <p:style>
-          <a:lnRef idx="1">
-            <a:schemeClr val="accent1"/>
-          </a:lnRef>
-          <a:fillRef idx="3">
-            <a:schemeClr val="accent1"/>
-          </a:fillRef>
-          <a:effectRef idx="2">
-            <a:schemeClr val="accent1"/>
-          </a:effectRef>
-          <a:fontRef idx="minor">
-            <a:schemeClr val="lt1"/>
-          </a:fontRef>
-        </p:style>
-        <p:txBody>
-          <a:bodyPr rtlCol="0" anchor="ctr"/>
-          <a:lstStyle/>
-          <a:p>
-            <a:pPr algn="ctr"/>
-          </a:p>
-        </p:txBody>
-      </p:sp>
-      <p:sp>
-        <p:nvSpPr>
-          <p:cNvPr id="10" name="TextBox 9"/>
-          <p:cNvSpPr txBox="1"/>
-          <p:nvPr/>
-        </p:nvSpPr>
-        <p:spPr>
-          <a:xfrm>
-            <a:off x="3566160" y="1664208"/>
-            <a:ext cx="2194560" cy="548640"/>
-          </a:xfrm>
-          <a:prstGeom prst="rect">
-            <a:avLst/>
-          </a:prstGeom>
-          <a:noFill/>
-        </p:spPr>
-        <p:txBody>
-          <a:bodyPr wrap="square" anchor="ctr">
-            <a:spAutoFit/>
-          </a:bodyPr>
-          <a:lstStyle/>
-          <a:p>
-            <a:pPr algn="ctr">
-              <a:spcAft>
-                <a:spcPts val="0"/>
-              </a:spcAft>
-            </a:pPr>
-            <a:r>
-              <a:rPr sz="2200" b="1">
-                <a:solidFill>
-                  <a:srgbClr val="2D9DB8"/>
-                </a:solidFill>
-                <a:latin typeface="Apple SD Gothic Neo"/>
-              </a:rPr>
-              <a:t>p = .0039</a:t>
-            </a:r>
-          </a:p>
-        </p:txBody>
-      </p:sp>
-      <p:sp>
-        <p:nvSpPr>
-          <p:cNvPr id="11" name="TextBox 10"/>
-          <p:cNvSpPr txBox="1"/>
-          <p:nvPr/>
-        </p:nvSpPr>
-        <p:spPr>
-          <a:xfrm>
-            <a:off x="3566160" y="2359152"/>
-            <a:ext cx="2194560" cy="594360"/>
-          </a:xfrm>
-          <a:prstGeom prst="rect">
-            <a:avLst/>
-          </a:prstGeom>
-          <a:noFill/>
-        </p:spPr>
-        <p:txBody>
-          <a:bodyPr wrap="square" anchor="ctr">
-            <a:spAutoFit/>
-          </a:bodyPr>
-          <a:lstStyle/>
-          <a:p>
-            <a:pPr algn="ctr">
-              <a:spcAft>
-                <a:spcPts val="0"/>
-              </a:spcAft>
-            </a:pPr>
-            <a:r>
-              <a:rPr sz="1150" b="1">
-                <a:solidFill>
-                  <a:srgbClr val="1A232F"/>
-                </a:solidFill>
-                <a:latin typeface="Apple SD Gothic Neo"/>
-              </a:rPr>
-              <a:t>domain exact
-sign test</a:t>
-            </a:r>
-          </a:p>
-        </p:txBody>
-      </p:sp>
-      <p:sp>
-        <p:nvSpPr>
-          <p:cNvPr id="12" name="Rounded Rectangle 11"/>
-          <p:cNvSpPr/>
-          <p:nvPr/>
-        </p:nvSpPr>
-        <p:spPr>
-          <a:xfrm>
-            <a:off x="6446520" y="1417320"/>
-            <a:ext cx="2194560" cy="1828800"/>
-          </a:xfrm>
-          <a:prstGeom prst="roundRect">
-            <a:avLst/>
-          </a:prstGeom>
-          <a:solidFill>
-            <a:srgbClr val="E7F6EF"/>
-          </a:solidFill>
-          <a:ln w="15240">
-            <a:solidFill>
-              <a:srgbClr val="2D9168"/>
-            </a:solidFill>
-          </a:ln>
-        </p:spPr>
-        <p:style>
-          <a:lnRef idx="1">
-            <a:schemeClr val="accent1"/>
-          </a:lnRef>
-          <a:fillRef idx="3">
-            <a:schemeClr val="accent1"/>
-          </a:fillRef>
-          <a:effectRef idx="2">
-            <a:schemeClr val="accent1"/>
-          </a:effectRef>
-          <a:fontRef idx="minor">
-            <a:schemeClr val="lt1"/>
-          </a:fontRef>
-        </p:style>
-        <p:txBody>
-          <a:bodyPr rtlCol="0" anchor="ctr"/>
-          <a:lstStyle/>
-          <a:p>
-            <a:pPr algn="ctr"/>
-          </a:p>
-        </p:txBody>
-      </p:sp>
-      <p:sp>
-        <p:nvSpPr>
-          <p:cNvPr id="13" name="TextBox 12"/>
-          <p:cNvSpPr txBox="1"/>
-          <p:nvPr/>
-        </p:nvSpPr>
-        <p:spPr>
-          <a:xfrm>
-            <a:off x="6446520" y="1664208"/>
-            <a:ext cx="2194560" cy="548640"/>
-          </a:xfrm>
-          <a:prstGeom prst="rect">
-            <a:avLst/>
-          </a:prstGeom>
-          <a:noFill/>
-        </p:spPr>
-        <p:txBody>
-          <a:bodyPr wrap="square" anchor="ctr">
-            <a:spAutoFit/>
-          </a:bodyPr>
-          <a:lstStyle/>
-          <a:p>
-            <a:pPr algn="ctr">
-              <a:spcAft>
-                <a:spcPts val="0"/>
-              </a:spcAft>
-            </a:pPr>
-            <a:r>
-              <a:rPr sz="2200" b="1">
-                <a:solidFill>
-                  <a:srgbClr val="2D9168"/>
-                </a:solidFill>
-                <a:latin typeface="Apple SD Gothic Neo"/>
-              </a:rPr>
-              <a:t>33.8%</a:t>
-            </a:r>
-          </a:p>
-        </p:txBody>
-      </p:sp>
-      <p:sp>
-        <p:nvSpPr>
-          <p:cNvPr id="14" name="TextBox 13"/>
-          <p:cNvSpPr txBox="1"/>
-          <p:nvPr/>
-        </p:nvSpPr>
-        <p:spPr>
-          <a:xfrm>
-            <a:off x="6446520" y="2359152"/>
-            <a:ext cx="2194560" cy="594360"/>
-          </a:xfrm>
-          <a:prstGeom prst="rect">
-            <a:avLst/>
-          </a:prstGeom>
-          <a:noFill/>
-        </p:spPr>
-        <p:txBody>
-          <a:bodyPr wrap="square" anchor="ctr">
-            <a:spAutoFit/>
-          </a:bodyPr>
-          <a:lstStyle/>
-          <a:p>
-            <a:pPr algn="ctr">
-              <a:spcAft>
-                <a:spcPts val="0"/>
-              </a:spcAft>
-            </a:pPr>
-            <a:r>
-              <a:rPr sz="1150" b="1">
-                <a:solidFill>
-                  <a:srgbClr val="1A232F"/>
-                </a:solidFill>
-                <a:latin typeface="Apple SD Gothic Neo"/>
-              </a:rPr>
-              <a:t>geometric-mean
-RMSE 감소</a:t>
-            </a:r>
-          </a:p>
-        </p:txBody>
-      </p:sp>
-      <p:sp>
-        <p:nvSpPr>
-          <p:cNvPr id="15" name="Rounded Rectangle 14"/>
-          <p:cNvSpPr/>
-          <p:nvPr/>
-        </p:nvSpPr>
-        <p:spPr>
-          <a:xfrm>
-            <a:off x="9326880" y="1417320"/>
-            <a:ext cx="2194560" cy="1828800"/>
-          </a:xfrm>
-          <a:prstGeom prst="roundRect">
-            <a:avLst/>
-          </a:prstGeom>
-          <a:solidFill>
-            <a:srgbClr val="FDF1E6"/>
-          </a:solidFill>
-          <a:ln w="15240">
-            <a:solidFill>
-              <a:srgbClr val="E67E34"/>
-            </a:solidFill>
-          </a:ln>
-        </p:spPr>
-        <p:style>
-          <a:lnRef idx="1">
-            <a:schemeClr val="accent1"/>
-          </a:lnRef>
-          <a:fillRef idx="3">
-            <a:schemeClr val="accent1"/>
-          </a:fillRef>
-          <a:effectRef idx="2">
-            <a:schemeClr val="accent1"/>
-          </a:effectRef>
-          <a:fontRef idx="minor">
-            <a:schemeClr val="lt1"/>
-          </a:fontRef>
-        </p:style>
-        <p:txBody>
-          <a:bodyPr rtlCol="0" anchor="ctr"/>
-          <a:lstStyle/>
-          <a:p>
-            <a:pPr algn="ctr"/>
-          </a:p>
-        </p:txBody>
-      </p:sp>
-      <p:sp>
-        <p:nvSpPr>
-          <p:cNvPr id="16" name="TextBox 15"/>
-          <p:cNvSpPr txBox="1"/>
-          <p:nvPr/>
-        </p:nvSpPr>
-        <p:spPr>
-          <a:xfrm>
-            <a:off x="9326880" y="1664208"/>
-            <a:ext cx="2194560" cy="548640"/>
-          </a:xfrm>
-          <a:prstGeom prst="rect">
-            <a:avLst/>
-          </a:prstGeom>
-          <a:noFill/>
-        </p:spPr>
-        <p:txBody>
-          <a:bodyPr wrap="square" anchor="ctr">
-            <a:spAutoFit/>
-          </a:bodyPr>
-          <a:lstStyle/>
-          <a:p>
-            <a:pPr algn="ctr">
-              <a:spcAft>
-                <a:spcPts val="0"/>
-              </a:spcAft>
-            </a:pPr>
-            <a:r>
-              <a:rPr sz="2200" b="1">
-                <a:solidFill>
-                  <a:srgbClr val="E67E34"/>
-                </a:solidFill>
-                <a:latin typeface="Apple SD Gothic Neo"/>
-              </a:rPr>
-              <a:t>[0.17, 0.67]</a:t>
-            </a:r>
-          </a:p>
-        </p:txBody>
-      </p:sp>
-      <p:sp>
-        <p:nvSpPr>
-          <p:cNvPr id="17" name="TextBox 16"/>
-          <p:cNvSpPr txBox="1"/>
-          <p:nvPr/>
-        </p:nvSpPr>
-        <p:spPr>
-          <a:xfrm>
-            <a:off x="9326880" y="2359152"/>
-            <a:ext cx="2194560" cy="594360"/>
-          </a:xfrm>
-          <a:prstGeom prst="rect">
-            <a:avLst/>
-          </a:prstGeom>
-          <a:noFill/>
-        </p:spPr>
-        <p:txBody>
-          <a:bodyPr wrap="square" anchor="ctr">
-            <a:spAutoFit/>
-          </a:bodyPr>
-          <a:lstStyle/>
-          <a:p>
-            <a:pPr algn="ctr">
-              <a:spcAft>
-                <a:spcPts val="0"/>
-              </a:spcAft>
-            </a:pPr>
-            <a:r>
-              <a:rPr sz="1150" b="1">
-                <a:solidFill>
-                  <a:srgbClr val="1A232F"/>
-                </a:solidFill>
-                <a:latin typeface="Apple SD Gothic Neo"/>
-              </a:rPr>
-              <a:t>hierarchical CI
-log-RMSE gain</a:t>
-            </a:r>
-          </a:p>
-        </p:txBody>
-      </p:sp>
-      <p:cxnSp>
-        <p:nvCxnSpPr>
-          <p:cNvPr id="18" name="Connector 17"/>
-          <p:cNvCxnSpPr/>
-          <p:nvPr/>
-        </p:nvCxnSpPr>
-        <p:spPr>
-          <a:xfrm>
-            <a:off x="914400" y="3749039"/>
-            <a:ext cx="10332720" cy="0"/>
-          </a:xfrm>
-          <a:prstGeom prst="line">
-            <a:avLst/>
-          </a:prstGeom>
-          <a:ln w="15240">
-            <a:solidFill>
-              <a:srgbClr val="DCE1E6"/>
-            </a:solidFill>
-          </a:ln>
-        </p:spPr>
-        <p:style>
-          <a:lnRef idx="2">
-            <a:schemeClr val="accent1"/>
-          </a:lnRef>
-          <a:fillRef idx="0">
-            <a:schemeClr val="accent1"/>
-          </a:fillRef>
-          <a:effectRef idx="1">
-            <a:schemeClr val="accent1"/>
-          </a:effectRef>
-          <a:fontRef idx="minor">
-            <a:schemeClr val="tx1"/>
-          </a:fontRef>
-        </p:style>
-      </p:cxnSp>
-      <p:sp>
-        <p:nvSpPr>
-          <p:cNvPr id="19" name="TextBox 18"/>
-          <p:cNvSpPr txBox="1"/>
-          <p:nvPr/>
-        </p:nvSpPr>
-        <p:spPr>
-          <a:xfrm>
-            <a:off x="822960" y="4069080"/>
-            <a:ext cx="2286000" cy="365760"/>
-          </a:xfrm>
-          <a:prstGeom prst="rect">
-            <a:avLst/>
-          </a:prstGeom>
-          <a:noFill/>
-        </p:spPr>
-        <p:txBody>
-          <a:bodyPr wrap="square" anchor="ctr">
-            <a:spAutoFit/>
-          </a:bodyPr>
-          <a:lstStyle/>
-          <a:p>
-            <a:pPr algn="l">
-              <a:spcAft>
-                <a:spcPts val="0"/>
-              </a:spcAft>
-            </a:pPr>
-            <a:r>
-              <a:rPr sz="1500" b="1">
-                <a:solidFill>
-                  <a:srgbClr val="1A232F"/>
-                </a:solidFill>
-                <a:latin typeface="Apple SD Gothic Neo"/>
-              </a:rPr>
-              <a:t>개별 BH 근거</a:t>
-            </a:r>
-          </a:p>
-        </p:txBody>
-      </p:sp>
-      <p:sp>
-        <p:nvSpPr>
-          <p:cNvPr id="20" name="Rounded Rectangle 19"/>
-          <p:cNvSpPr/>
-          <p:nvPr/>
-        </p:nvSpPr>
-        <p:spPr>
-          <a:xfrm>
-            <a:off x="2743200" y="4087368"/>
-            <a:ext cx="1417320" cy="329184"/>
+            <a:off x="9528048" y="4187952"/>
+            <a:ext cx="1664208" cy="329184"/>
           </a:xfrm>
           <a:prstGeom prst="roundRect">
             <a:avLst/>
@@ -5724,14 +5305,14 @@
       </p:sp>
       <p:sp>
         <p:nvSpPr>
-          <p:cNvPr id="21" name="TextBox 20"/>
-          <p:cNvSpPr txBox="1"/>
-          <p:nvPr/>
-        </p:nvSpPr>
-        <p:spPr>
-          <a:xfrm>
-            <a:off x="2743200" y="4087368"/>
-            <a:ext cx="1417320" cy="329184"/>
+          <p:cNvPr id="11" name="TextBox 10"/>
+          <p:cNvSpPr txBox="1"/>
+          <p:nvPr/>
+        </p:nvSpPr>
+        <p:spPr>
+          <a:xfrm>
+            <a:off x="9528048" y="4187952"/>
+            <a:ext cx="1664208" cy="329184"/>
           </a:xfrm>
           <a:prstGeom prst="rect">
             <a:avLst/>
@@ -5756,66 +5337,21 @@
                 </a:solidFill>
                 <a:latin typeface="Apple SD Gothic Neo"/>
               </a:rPr>
-              <a:t>Sunwoda</a:t>
-            </a:r>
-          </a:p>
-        </p:txBody>
-      </p:sp>
-      <p:sp>
-        <p:nvSpPr>
-          <p:cNvPr id="22" name="Rounded Rectangle 21"/>
-          <p:cNvSpPr/>
-          <p:nvPr/>
-        </p:nvSpPr>
-        <p:spPr>
-          <a:xfrm>
-            <a:off x="4343400" y="4087368"/>
-            <a:ext cx="1417320" cy="329184"/>
-          </a:xfrm>
-          <a:prstGeom prst="roundRect">
-            <a:avLst/>
-          </a:prstGeom>
-          <a:solidFill>
-            <a:srgbClr val="2D9168"/>
-          </a:solidFill>
-          <a:ln w="15240">
-            <a:solidFill>
-              <a:srgbClr val="2D9168"/>
-            </a:solidFill>
-          </a:ln>
-        </p:spPr>
-        <p:style>
-          <a:lnRef idx="1">
-            <a:schemeClr val="accent1"/>
-          </a:lnRef>
-          <a:fillRef idx="3">
-            <a:schemeClr val="accent1"/>
-          </a:fillRef>
-          <a:effectRef idx="2">
-            <a:schemeClr val="accent1"/>
-          </a:effectRef>
-          <a:fontRef idx="minor">
-            <a:schemeClr val="lt1"/>
-          </a:fontRef>
-        </p:style>
-        <p:txBody>
-          <a:bodyPr rtlCol="0" anchor="ctr"/>
-          <a:lstStyle/>
-          <a:p>
-            <a:pPr algn="ctr"/>
-          </a:p>
-        </p:txBody>
-      </p:sp>
-      <p:sp>
-        <p:nvSpPr>
-          <p:cNvPr id="23" name="TextBox 22"/>
-          <p:cNvSpPr txBox="1"/>
-          <p:nvPr/>
-        </p:nvSpPr>
-        <p:spPr>
-          <a:xfrm>
-            <a:off x="4343400" y="4087368"/>
-            <a:ext cx="1417320" cy="329184"/>
+              <a:t>R²&gt;0  9/9</a:t>
+            </a:r>
+          </a:p>
+        </p:txBody>
+      </p:sp>
+      <p:sp>
+        <p:nvSpPr>
+          <p:cNvPr id="12" name="TextBox 11"/>
+          <p:cNvSpPr txBox="1"/>
+          <p:nvPr/>
+        </p:nvSpPr>
+        <p:spPr>
+          <a:xfrm>
+            <a:off x="9098280" y="5257800"/>
+            <a:ext cx="2468880" cy="685800"/>
           </a:xfrm>
           <a:prstGeom prst="rect">
             <a:avLst/>
@@ -5834,176 +5370,14 @@
               </a:spcAft>
             </a:pPr>
             <a:r>
-              <a:rPr sz="1100" b="1">
-                <a:solidFill>
-                  <a:srgbClr val="FFFFFF"/>
-                </a:solidFill>
-                <a:latin typeface="Apple SD Gothic Neo"/>
-              </a:rPr>
-              <a:t>MATR-b2</a:t>
-            </a:r>
-          </a:p>
-        </p:txBody>
-      </p:sp>
-      <p:sp>
-        <p:nvSpPr>
-          <p:cNvPr id="24" name="TextBox 23"/>
-          <p:cNvSpPr txBox="1"/>
-          <p:nvPr/>
-        </p:nvSpPr>
-        <p:spPr>
-          <a:xfrm>
-            <a:off x="822960" y="4800600"/>
-            <a:ext cx="2286000" cy="365760"/>
-          </a:xfrm>
-          <a:prstGeom prst="rect">
-            <a:avLst/>
-          </a:prstGeom>
-          <a:noFill/>
-        </p:spPr>
-        <p:txBody>
-          <a:bodyPr wrap="square" anchor="ctr">
-            <a:spAutoFit/>
-          </a:bodyPr>
-          <a:lstStyle/>
-          <a:p>
-            <a:pPr algn="l">
-              <a:spcAft>
-                <a:spcPts val="0"/>
-              </a:spcAft>
-            </a:pPr>
-            <a:r>
-              <a:rPr sz="1500" b="1">
+              <a:rPr sz="1250" b="1">
                 <a:solidFill>
                   <a:srgbClr val="1A232F"/>
                 </a:solidFill>
                 <a:latin typeface="Apple SD Gothic Neo"/>
               </a:rPr>
-              <a:t>해석 제한</a:t>
-            </a:r>
-          </a:p>
-        </p:txBody>
-      </p:sp>
-      <p:sp>
-        <p:nvSpPr>
-          <p:cNvPr id="25" name="TextBox 24"/>
-          <p:cNvSpPr txBox="1"/>
-          <p:nvPr/>
-        </p:nvSpPr>
-        <p:spPr>
-          <a:xfrm>
-            <a:off x="2743200" y="4690872"/>
-            <a:ext cx="8046720" cy="731520"/>
-          </a:xfrm>
-          <a:prstGeom prst="rect">
-            <a:avLst/>
-          </a:prstGeom>
-          <a:noFill/>
-        </p:spPr>
-        <p:txBody>
-          <a:bodyPr wrap="square" anchor="ctr">
-            <a:spAutoFit/>
-          </a:bodyPr>
-          <a:lstStyle/>
-          <a:p>
-            <a:pPr algn="l">
-              <a:spcAft>
-                <a:spcPts val="0"/>
-              </a:spcAft>
-            </a:pPr>
-            <a:r>
-              <a:rPr sz="1250" b="1">
-                <a:solidFill>
-                  <a:srgbClr val="5B6777"/>
-                </a:solidFill>
-                <a:latin typeface="Apple SD Gothic Neo"/>
-              </a:rPr>
-              <a:t>5 seeds는 독립 cohort가 아님 · NASA/N-CMAPSS unit 수가 작음
-retrospective split은 prospective 확증을 대체하지 않음</a:t>
-            </a:r>
-          </a:p>
-        </p:txBody>
-      </p:sp>
-      <p:sp>
-        <p:nvSpPr>
-          <p:cNvPr id="26" name="Rounded Rectangle 25"/>
-          <p:cNvSpPr/>
-          <p:nvPr/>
-        </p:nvSpPr>
-        <p:spPr>
-          <a:xfrm>
-            <a:off x="822960" y="5715000"/>
-            <a:ext cx="10698480" cy="502920"/>
-          </a:xfrm>
-          <a:prstGeom prst="roundRect">
-            <a:avLst/>
-          </a:prstGeom>
-          <a:solidFill>
-            <a:srgbClr val="FBEBEB"/>
-          </a:solidFill>
-          <a:ln w="15240">
-            <a:solidFill>
-              <a:srgbClr val="BE4141"/>
-            </a:solidFill>
-          </a:ln>
-        </p:spPr>
-        <p:style>
-          <a:lnRef idx="1">
-            <a:schemeClr val="accent1"/>
-          </a:lnRef>
-          <a:fillRef idx="3">
-            <a:schemeClr val="accent1"/>
-          </a:fillRef>
-          <a:effectRef idx="2">
-            <a:schemeClr val="accent1"/>
-          </a:effectRef>
-          <a:fontRef idx="minor">
-            <a:schemeClr val="lt1"/>
-          </a:fontRef>
-        </p:style>
-        <p:txBody>
-          <a:bodyPr rtlCol="0" anchor="ctr"/>
-          <a:lstStyle/>
-          <a:p>
-            <a:pPr algn="ctr"/>
-          </a:p>
-        </p:txBody>
-      </p:sp>
-      <p:sp>
-        <p:nvSpPr>
-          <p:cNvPr id="27" name="TextBox 26"/>
-          <p:cNvSpPr txBox="1"/>
-          <p:nvPr/>
-        </p:nvSpPr>
-        <p:spPr>
-          <a:xfrm>
-            <a:off x="1051560" y="5769864"/>
-            <a:ext cx="10241280" cy="384048"/>
-          </a:xfrm>
-          <a:prstGeom prst="rect">
-            <a:avLst/>
-          </a:prstGeom>
-          <a:noFill/>
-        </p:spPr>
-        <p:txBody>
-          <a:bodyPr wrap="square" anchor="ctr">
-            <a:spAutoFit/>
-          </a:bodyPr>
-          <a:lstStyle/>
-          <a:p>
-            <a:pPr algn="ctr">
-              <a:spcAft>
-                <a:spcPts val="0"/>
-              </a:spcAft>
-            </a:pPr>
-            <a:r>
-              <a:rPr sz="1200" b="1">
-                <a:solidFill>
-                  <a:srgbClr val="BE4141"/>
-                </a:solidFill>
-                <a:latin typeface="Apple SD Gothic Neo"/>
-              </a:rPr>
-              <a:t>FEMTO v1_declared abstention은 Final BH family에서 제외</a:t>
+              <a:t>관찰 범위에서
+심한 음의 tail이 없음</a:t>
             </a:r>
           </a:p>
         </p:txBody>
@@ -6068,7 +5442,7 @@
                 </a:solidFill>
                 <a:latin typeface="Apple SD Gothic Neo"/>
               </a:rPr>
-              <a:t>무엇을 주장하고, 무엇을 주장하지 않는가</a:t>
+              <a:t>통계검정 — 행이 아니라 물리 unit이 표본</a:t>
             </a:r>
           </a:p>
         </p:txBody>
@@ -6107,7 +5481,7 @@
                 </a:solidFill>
                 <a:latin typeface="Apple SD Gothic Neo"/>
               </a:rPr>
-              <a:t>성과보다 실행 계약의 범위를 먼저 고정한다.</a:t>
+              <a:t>요약 효과와 개별 component evidence를 분리한다.</a:t>
             </a:r>
           </a:p>
         </p:txBody>
@@ -6194,8 +5568,256 @@
         </p:nvSpPr>
         <p:spPr>
           <a:xfrm>
-            <a:off x="658368" y="1325880"/>
-            <a:ext cx="5257800" cy="4434840"/>
+            <a:off x="685800" y="1417320"/>
+            <a:ext cx="2194560" cy="1828800"/>
+          </a:xfrm>
+          <a:prstGeom prst="roundRect">
+            <a:avLst/>
+          </a:prstGeom>
+          <a:solidFill>
+            <a:srgbClr val="E9F3FB"/>
+          </a:solidFill>
+          <a:ln w="15240">
+            <a:solidFill>
+              <a:srgbClr val="1F6BB5"/>
+            </a:solidFill>
+          </a:ln>
+        </p:spPr>
+        <p:style>
+          <a:lnRef idx="1">
+            <a:schemeClr val="accent1"/>
+          </a:lnRef>
+          <a:fillRef idx="3">
+            <a:schemeClr val="accent1"/>
+          </a:fillRef>
+          <a:effectRef idx="2">
+            <a:schemeClr val="accent1"/>
+          </a:effectRef>
+          <a:fontRef idx="minor">
+            <a:schemeClr val="lt1"/>
+          </a:fontRef>
+        </p:style>
+        <p:txBody>
+          <a:bodyPr rtlCol="0" anchor="ctr"/>
+          <a:lstStyle/>
+          <a:p>
+            <a:pPr algn="ctr"/>
+          </a:p>
+        </p:txBody>
+      </p:sp>
+      <p:sp>
+        <p:nvSpPr>
+          <p:cNvPr id="7" name="TextBox 6"/>
+          <p:cNvSpPr txBox="1"/>
+          <p:nvPr/>
+        </p:nvSpPr>
+        <p:spPr>
+          <a:xfrm>
+            <a:off x="685800" y="1664208"/>
+            <a:ext cx="2194560" cy="548640"/>
+          </a:xfrm>
+          <a:prstGeom prst="rect">
+            <a:avLst/>
+          </a:prstGeom>
+          <a:noFill/>
+        </p:spPr>
+        <p:txBody>
+          <a:bodyPr wrap="square" anchor="ctr">
+            <a:spAutoFit/>
+          </a:bodyPr>
+          <a:lstStyle/>
+          <a:p>
+            <a:pPr algn="ctr">
+              <a:spcAft>
+                <a:spcPts val="0"/>
+              </a:spcAft>
+            </a:pPr>
+            <a:r>
+              <a:rPr sz="2200" b="1">
+                <a:solidFill>
+                  <a:srgbClr val="1F6BB5"/>
+                </a:solidFill>
+                <a:latin typeface="Apple SD Gothic Neo"/>
+              </a:rPr>
+              <a:t>9 / 9</a:t>
+            </a:r>
+          </a:p>
+        </p:txBody>
+      </p:sp>
+      <p:sp>
+        <p:nvSpPr>
+          <p:cNvPr id="8" name="TextBox 7"/>
+          <p:cNvSpPr txBox="1"/>
+          <p:nvPr/>
+        </p:nvSpPr>
+        <p:spPr>
+          <a:xfrm>
+            <a:off x="685800" y="2359152"/>
+            <a:ext cx="2194560" cy="594360"/>
+          </a:xfrm>
+          <a:prstGeom prst="rect">
+            <a:avLst/>
+          </a:prstGeom>
+          <a:noFill/>
+        </p:spPr>
+        <p:txBody>
+          <a:bodyPr wrap="square" anchor="ctr">
+            <a:spAutoFit/>
+          </a:bodyPr>
+          <a:lstStyle/>
+          <a:p>
+            <a:pPr algn="ctr">
+              <a:spcAft>
+                <a:spcPts val="0"/>
+              </a:spcAft>
+            </a:pPr>
+            <a:r>
+              <a:rPr sz="1150" b="1">
+                <a:solidFill>
+                  <a:srgbClr val="1A232F"/>
+                </a:solidFill>
+                <a:latin typeface="Apple SD Gothic Neo"/>
+              </a:rPr>
+              <a:t>vs matched direct
+방향 일치</a:t>
+            </a:r>
+          </a:p>
+        </p:txBody>
+      </p:sp>
+      <p:sp>
+        <p:nvSpPr>
+          <p:cNvPr id="9" name="Rounded Rectangle 8"/>
+          <p:cNvSpPr/>
+          <p:nvPr/>
+        </p:nvSpPr>
+        <p:spPr>
+          <a:xfrm>
+            <a:off x="3566160" y="1417320"/>
+            <a:ext cx="2194560" cy="1828800"/>
+          </a:xfrm>
+          <a:prstGeom prst="roundRect">
+            <a:avLst/>
+          </a:prstGeom>
+          <a:solidFill>
+            <a:srgbClr val="E6F7F9"/>
+          </a:solidFill>
+          <a:ln w="15240">
+            <a:solidFill>
+              <a:srgbClr val="2D9DB8"/>
+            </a:solidFill>
+          </a:ln>
+        </p:spPr>
+        <p:style>
+          <a:lnRef idx="1">
+            <a:schemeClr val="accent1"/>
+          </a:lnRef>
+          <a:fillRef idx="3">
+            <a:schemeClr val="accent1"/>
+          </a:fillRef>
+          <a:effectRef idx="2">
+            <a:schemeClr val="accent1"/>
+          </a:effectRef>
+          <a:fontRef idx="minor">
+            <a:schemeClr val="lt1"/>
+          </a:fontRef>
+        </p:style>
+        <p:txBody>
+          <a:bodyPr rtlCol="0" anchor="ctr"/>
+          <a:lstStyle/>
+          <a:p>
+            <a:pPr algn="ctr"/>
+          </a:p>
+        </p:txBody>
+      </p:sp>
+      <p:sp>
+        <p:nvSpPr>
+          <p:cNvPr id="10" name="TextBox 9"/>
+          <p:cNvSpPr txBox="1"/>
+          <p:nvPr/>
+        </p:nvSpPr>
+        <p:spPr>
+          <a:xfrm>
+            <a:off x="3566160" y="1664208"/>
+            <a:ext cx="2194560" cy="548640"/>
+          </a:xfrm>
+          <a:prstGeom prst="rect">
+            <a:avLst/>
+          </a:prstGeom>
+          <a:noFill/>
+        </p:spPr>
+        <p:txBody>
+          <a:bodyPr wrap="square" anchor="ctr">
+            <a:spAutoFit/>
+          </a:bodyPr>
+          <a:lstStyle/>
+          <a:p>
+            <a:pPr algn="ctr">
+              <a:spcAft>
+                <a:spcPts val="0"/>
+              </a:spcAft>
+            </a:pPr>
+            <a:r>
+              <a:rPr sz="2200" b="1">
+                <a:solidFill>
+                  <a:srgbClr val="2D9DB8"/>
+                </a:solidFill>
+                <a:latin typeface="Apple SD Gothic Neo"/>
+              </a:rPr>
+              <a:t>p = .0039</a:t>
+            </a:r>
+          </a:p>
+        </p:txBody>
+      </p:sp>
+      <p:sp>
+        <p:nvSpPr>
+          <p:cNvPr id="11" name="TextBox 10"/>
+          <p:cNvSpPr txBox="1"/>
+          <p:nvPr/>
+        </p:nvSpPr>
+        <p:spPr>
+          <a:xfrm>
+            <a:off x="3566160" y="2359152"/>
+            <a:ext cx="2194560" cy="594360"/>
+          </a:xfrm>
+          <a:prstGeom prst="rect">
+            <a:avLst/>
+          </a:prstGeom>
+          <a:noFill/>
+        </p:spPr>
+        <p:txBody>
+          <a:bodyPr wrap="square" anchor="ctr">
+            <a:spAutoFit/>
+          </a:bodyPr>
+          <a:lstStyle/>
+          <a:p>
+            <a:pPr algn="ctr">
+              <a:spcAft>
+                <a:spcPts val="0"/>
+              </a:spcAft>
+            </a:pPr>
+            <a:r>
+              <a:rPr sz="1150" b="1">
+                <a:solidFill>
+                  <a:srgbClr val="1A232F"/>
+                </a:solidFill>
+                <a:latin typeface="Apple SD Gothic Neo"/>
+              </a:rPr>
+              <a:t>domain exact
+sign test</a:t>
+            </a:r>
+          </a:p>
+        </p:txBody>
+      </p:sp>
+      <p:sp>
+        <p:nvSpPr>
+          <p:cNvPr id="12" name="Rounded Rectangle 11"/>
+          <p:cNvSpPr/>
+          <p:nvPr/>
+        </p:nvSpPr>
+        <p:spPr>
+          <a:xfrm>
+            <a:off x="6446520" y="1417320"/>
+            <a:ext cx="2194560" cy="1828800"/>
           </a:xfrm>
           <a:prstGeom prst="roundRect">
             <a:avLst/>
@@ -6233,14 +5855,252 @@
       </p:sp>
       <p:sp>
         <p:nvSpPr>
-          <p:cNvPr id="7" name="TextBox 6"/>
-          <p:cNvSpPr txBox="1"/>
-          <p:nvPr/>
-        </p:nvSpPr>
-        <p:spPr>
-          <a:xfrm>
-            <a:off x="960120" y="1600200"/>
-            <a:ext cx="4663440" cy="411480"/>
+          <p:cNvPr id="13" name="TextBox 12"/>
+          <p:cNvSpPr txBox="1"/>
+          <p:nvPr/>
+        </p:nvSpPr>
+        <p:spPr>
+          <a:xfrm>
+            <a:off x="6446520" y="1664208"/>
+            <a:ext cx="2194560" cy="548640"/>
+          </a:xfrm>
+          <a:prstGeom prst="rect">
+            <a:avLst/>
+          </a:prstGeom>
+          <a:noFill/>
+        </p:spPr>
+        <p:txBody>
+          <a:bodyPr wrap="square" anchor="ctr">
+            <a:spAutoFit/>
+          </a:bodyPr>
+          <a:lstStyle/>
+          <a:p>
+            <a:pPr algn="ctr">
+              <a:spcAft>
+                <a:spcPts val="0"/>
+              </a:spcAft>
+            </a:pPr>
+            <a:r>
+              <a:rPr sz="2200" b="1">
+                <a:solidFill>
+                  <a:srgbClr val="2D9168"/>
+                </a:solidFill>
+                <a:latin typeface="Apple SD Gothic Neo"/>
+              </a:rPr>
+              <a:t>33.8%</a:t>
+            </a:r>
+          </a:p>
+        </p:txBody>
+      </p:sp>
+      <p:sp>
+        <p:nvSpPr>
+          <p:cNvPr id="14" name="TextBox 13"/>
+          <p:cNvSpPr txBox="1"/>
+          <p:nvPr/>
+        </p:nvSpPr>
+        <p:spPr>
+          <a:xfrm>
+            <a:off x="6446520" y="2359152"/>
+            <a:ext cx="2194560" cy="594360"/>
+          </a:xfrm>
+          <a:prstGeom prst="rect">
+            <a:avLst/>
+          </a:prstGeom>
+          <a:noFill/>
+        </p:spPr>
+        <p:txBody>
+          <a:bodyPr wrap="square" anchor="ctr">
+            <a:spAutoFit/>
+          </a:bodyPr>
+          <a:lstStyle/>
+          <a:p>
+            <a:pPr algn="ctr">
+              <a:spcAft>
+                <a:spcPts val="0"/>
+              </a:spcAft>
+            </a:pPr>
+            <a:r>
+              <a:rPr sz="1150" b="1">
+                <a:solidFill>
+                  <a:srgbClr val="1A232F"/>
+                </a:solidFill>
+                <a:latin typeface="Apple SD Gothic Neo"/>
+              </a:rPr>
+              <a:t>geometric-mean
+RMSE 감소</a:t>
+            </a:r>
+          </a:p>
+        </p:txBody>
+      </p:sp>
+      <p:sp>
+        <p:nvSpPr>
+          <p:cNvPr id="15" name="Rounded Rectangle 14"/>
+          <p:cNvSpPr/>
+          <p:nvPr/>
+        </p:nvSpPr>
+        <p:spPr>
+          <a:xfrm>
+            <a:off x="9326880" y="1417320"/>
+            <a:ext cx="2194560" cy="1828800"/>
+          </a:xfrm>
+          <a:prstGeom prst="roundRect">
+            <a:avLst/>
+          </a:prstGeom>
+          <a:solidFill>
+            <a:srgbClr val="FDF1E6"/>
+          </a:solidFill>
+          <a:ln w="15240">
+            <a:solidFill>
+              <a:srgbClr val="E67E34"/>
+            </a:solidFill>
+          </a:ln>
+        </p:spPr>
+        <p:style>
+          <a:lnRef idx="1">
+            <a:schemeClr val="accent1"/>
+          </a:lnRef>
+          <a:fillRef idx="3">
+            <a:schemeClr val="accent1"/>
+          </a:fillRef>
+          <a:effectRef idx="2">
+            <a:schemeClr val="accent1"/>
+          </a:effectRef>
+          <a:fontRef idx="minor">
+            <a:schemeClr val="lt1"/>
+          </a:fontRef>
+        </p:style>
+        <p:txBody>
+          <a:bodyPr rtlCol="0" anchor="ctr"/>
+          <a:lstStyle/>
+          <a:p>
+            <a:pPr algn="ctr"/>
+          </a:p>
+        </p:txBody>
+      </p:sp>
+      <p:sp>
+        <p:nvSpPr>
+          <p:cNvPr id="16" name="TextBox 15"/>
+          <p:cNvSpPr txBox="1"/>
+          <p:nvPr/>
+        </p:nvSpPr>
+        <p:spPr>
+          <a:xfrm>
+            <a:off x="9326880" y="1664208"/>
+            <a:ext cx="2194560" cy="548640"/>
+          </a:xfrm>
+          <a:prstGeom prst="rect">
+            <a:avLst/>
+          </a:prstGeom>
+          <a:noFill/>
+        </p:spPr>
+        <p:txBody>
+          <a:bodyPr wrap="square" anchor="ctr">
+            <a:spAutoFit/>
+          </a:bodyPr>
+          <a:lstStyle/>
+          <a:p>
+            <a:pPr algn="ctr">
+              <a:spcAft>
+                <a:spcPts val="0"/>
+              </a:spcAft>
+            </a:pPr>
+            <a:r>
+              <a:rPr sz="2200" b="1">
+                <a:solidFill>
+                  <a:srgbClr val="E67E34"/>
+                </a:solidFill>
+                <a:latin typeface="Apple SD Gothic Neo"/>
+              </a:rPr>
+              <a:t>[0.17, 0.67]</a:t>
+            </a:r>
+          </a:p>
+        </p:txBody>
+      </p:sp>
+      <p:sp>
+        <p:nvSpPr>
+          <p:cNvPr id="17" name="TextBox 16"/>
+          <p:cNvSpPr txBox="1"/>
+          <p:nvPr/>
+        </p:nvSpPr>
+        <p:spPr>
+          <a:xfrm>
+            <a:off x="9326880" y="2359152"/>
+            <a:ext cx="2194560" cy="594360"/>
+          </a:xfrm>
+          <a:prstGeom prst="rect">
+            <a:avLst/>
+          </a:prstGeom>
+          <a:noFill/>
+        </p:spPr>
+        <p:txBody>
+          <a:bodyPr wrap="square" anchor="ctr">
+            <a:spAutoFit/>
+          </a:bodyPr>
+          <a:lstStyle/>
+          <a:p>
+            <a:pPr algn="ctr">
+              <a:spcAft>
+                <a:spcPts val="0"/>
+              </a:spcAft>
+            </a:pPr>
+            <a:r>
+              <a:rPr sz="1150" b="1">
+                <a:solidFill>
+                  <a:srgbClr val="1A232F"/>
+                </a:solidFill>
+                <a:latin typeface="Apple SD Gothic Neo"/>
+              </a:rPr>
+              <a:t>hierarchical CI
+log-RMSE gain</a:t>
+            </a:r>
+          </a:p>
+        </p:txBody>
+      </p:sp>
+      <p:cxnSp>
+        <p:nvCxnSpPr>
+          <p:cNvPr id="18" name="Connector 17"/>
+          <p:cNvCxnSpPr/>
+          <p:nvPr/>
+        </p:nvCxnSpPr>
+        <p:spPr>
+          <a:xfrm>
+            <a:off x="914400" y="3749039"/>
+            <a:ext cx="10332720" cy="0"/>
+          </a:xfrm>
+          <a:prstGeom prst="line">
+            <a:avLst/>
+          </a:prstGeom>
+          <a:ln w="15240">
+            <a:solidFill>
+              <a:srgbClr val="DCE1E6"/>
+            </a:solidFill>
+          </a:ln>
+        </p:spPr>
+        <p:style>
+          <a:lnRef idx="2">
+            <a:schemeClr val="accent1"/>
+          </a:lnRef>
+          <a:fillRef idx="0">
+            <a:schemeClr val="accent1"/>
+          </a:fillRef>
+          <a:effectRef idx="1">
+            <a:schemeClr val="accent1"/>
+          </a:effectRef>
+          <a:fontRef idx="minor">
+            <a:schemeClr val="tx1"/>
+          </a:fontRef>
+        </p:style>
+      </p:cxnSp>
+      <p:sp>
+        <p:nvSpPr>
+          <p:cNvPr id="19" name="TextBox 18"/>
+          <p:cNvSpPr txBox="1"/>
+          <p:nvPr/>
+        </p:nvSpPr>
+        <p:spPr>
+          <a:xfrm>
+            <a:off x="822960" y="4069080"/>
+            <a:ext cx="2286000" cy="365760"/>
           </a:xfrm>
           <a:prstGeom prst="rect">
             <a:avLst/>
@@ -6259,27 +6119,195 @@
               </a:spcAft>
             </a:pPr>
             <a:r>
-              <a:rPr sz="2100" b="1">
-                <a:solidFill>
-                  <a:srgbClr val="2D9168"/>
-                </a:solidFill>
-                <a:latin typeface="Apple SD Gothic Neo"/>
-              </a:rPr>
-              <a:t>말할 수 있음</a:t>
-            </a:r>
-          </a:p>
-        </p:txBody>
-      </p:sp>
-      <p:sp>
-        <p:nvSpPr>
-          <p:cNvPr id="8" name="TextBox 7"/>
-          <p:cNvSpPr txBox="1"/>
-          <p:nvPr/>
-        </p:nvSpPr>
-        <p:spPr>
-          <a:xfrm>
-            <a:off x="960120" y="2304288"/>
-            <a:ext cx="4617720" cy="2560320"/>
+              <a:rPr sz="1500" b="1">
+                <a:solidFill>
+                  <a:srgbClr val="1A232F"/>
+                </a:solidFill>
+                <a:latin typeface="Apple SD Gothic Neo"/>
+              </a:rPr>
+              <a:t>개별 BH 근거</a:t>
+            </a:r>
+          </a:p>
+        </p:txBody>
+      </p:sp>
+      <p:sp>
+        <p:nvSpPr>
+          <p:cNvPr id="20" name="Rounded Rectangle 19"/>
+          <p:cNvSpPr/>
+          <p:nvPr/>
+        </p:nvSpPr>
+        <p:spPr>
+          <a:xfrm>
+            <a:off x="2743200" y="4087368"/>
+            <a:ext cx="1417320" cy="329184"/>
+          </a:xfrm>
+          <a:prstGeom prst="roundRect">
+            <a:avLst/>
+          </a:prstGeom>
+          <a:solidFill>
+            <a:srgbClr val="1F6BB5"/>
+          </a:solidFill>
+          <a:ln w="15240">
+            <a:solidFill>
+              <a:srgbClr val="1F6BB5"/>
+            </a:solidFill>
+          </a:ln>
+        </p:spPr>
+        <p:style>
+          <a:lnRef idx="1">
+            <a:schemeClr val="accent1"/>
+          </a:lnRef>
+          <a:fillRef idx="3">
+            <a:schemeClr val="accent1"/>
+          </a:fillRef>
+          <a:effectRef idx="2">
+            <a:schemeClr val="accent1"/>
+          </a:effectRef>
+          <a:fontRef idx="minor">
+            <a:schemeClr val="lt1"/>
+          </a:fontRef>
+        </p:style>
+        <p:txBody>
+          <a:bodyPr rtlCol="0" anchor="ctr"/>
+          <a:lstStyle/>
+          <a:p>
+            <a:pPr algn="ctr"/>
+          </a:p>
+        </p:txBody>
+      </p:sp>
+      <p:sp>
+        <p:nvSpPr>
+          <p:cNvPr id="21" name="TextBox 20"/>
+          <p:cNvSpPr txBox="1"/>
+          <p:nvPr/>
+        </p:nvSpPr>
+        <p:spPr>
+          <a:xfrm>
+            <a:off x="2743200" y="4087368"/>
+            <a:ext cx="1417320" cy="329184"/>
+          </a:xfrm>
+          <a:prstGeom prst="rect">
+            <a:avLst/>
+          </a:prstGeom>
+          <a:noFill/>
+        </p:spPr>
+        <p:txBody>
+          <a:bodyPr wrap="square" anchor="ctr">
+            <a:spAutoFit/>
+          </a:bodyPr>
+          <a:lstStyle/>
+          <a:p>
+            <a:pPr algn="ctr">
+              <a:spcAft>
+                <a:spcPts val="0"/>
+              </a:spcAft>
+            </a:pPr>
+            <a:r>
+              <a:rPr sz="1100" b="1">
+                <a:solidFill>
+                  <a:srgbClr val="FFFFFF"/>
+                </a:solidFill>
+                <a:latin typeface="Apple SD Gothic Neo"/>
+              </a:rPr>
+              <a:t>Sunwoda</a:t>
+            </a:r>
+          </a:p>
+        </p:txBody>
+      </p:sp>
+      <p:sp>
+        <p:nvSpPr>
+          <p:cNvPr id="22" name="Rounded Rectangle 21"/>
+          <p:cNvSpPr/>
+          <p:nvPr/>
+        </p:nvSpPr>
+        <p:spPr>
+          <a:xfrm>
+            <a:off x="4343400" y="4087368"/>
+            <a:ext cx="1417320" cy="329184"/>
+          </a:xfrm>
+          <a:prstGeom prst="roundRect">
+            <a:avLst/>
+          </a:prstGeom>
+          <a:solidFill>
+            <a:srgbClr val="2D9168"/>
+          </a:solidFill>
+          <a:ln w="15240">
+            <a:solidFill>
+              <a:srgbClr val="2D9168"/>
+            </a:solidFill>
+          </a:ln>
+        </p:spPr>
+        <p:style>
+          <a:lnRef idx="1">
+            <a:schemeClr val="accent1"/>
+          </a:lnRef>
+          <a:fillRef idx="3">
+            <a:schemeClr val="accent1"/>
+          </a:fillRef>
+          <a:effectRef idx="2">
+            <a:schemeClr val="accent1"/>
+          </a:effectRef>
+          <a:fontRef idx="minor">
+            <a:schemeClr val="lt1"/>
+          </a:fontRef>
+        </p:style>
+        <p:txBody>
+          <a:bodyPr rtlCol="0" anchor="ctr"/>
+          <a:lstStyle/>
+          <a:p>
+            <a:pPr algn="ctr"/>
+          </a:p>
+        </p:txBody>
+      </p:sp>
+      <p:sp>
+        <p:nvSpPr>
+          <p:cNvPr id="23" name="TextBox 22"/>
+          <p:cNvSpPr txBox="1"/>
+          <p:nvPr/>
+        </p:nvSpPr>
+        <p:spPr>
+          <a:xfrm>
+            <a:off x="4343400" y="4087368"/>
+            <a:ext cx="1417320" cy="329184"/>
+          </a:xfrm>
+          <a:prstGeom prst="rect">
+            <a:avLst/>
+          </a:prstGeom>
+          <a:noFill/>
+        </p:spPr>
+        <p:txBody>
+          <a:bodyPr wrap="square" anchor="ctr">
+            <a:spAutoFit/>
+          </a:bodyPr>
+          <a:lstStyle/>
+          <a:p>
+            <a:pPr algn="ctr">
+              <a:spcAft>
+                <a:spcPts val="0"/>
+              </a:spcAft>
+            </a:pPr>
+            <a:r>
+              <a:rPr sz="1100" b="1">
+                <a:solidFill>
+                  <a:srgbClr val="FFFFFF"/>
+                </a:solidFill>
+                <a:latin typeface="Apple SD Gothic Neo"/>
+              </a:rPr>
+              <a:t>MATR-b2</a:t>
+            </a:r>
+          </a:p>
+        </p:txBody>
+      </p:sp>
+      <p:sp>
+        <p:nvSpPr>
+          <p:cNvPr id="24" name="TextBox 23"/>
+          <p:cNvSpPr txBox="1"/>
+          <p:nvPr/>
+        </p:nvSpPr>
+        <p:spPr>
+          <a:xfrm>
+            <a:off x="822960" y="4800600"/>
+            <a:ext cx="2286000" cy="365760"/>
           </a:xfrm>
           <a:prstGeom prst="rect">
             <a:avLst/>
@@ -6298,30 +6326,67 @@
               </a:spcAft>
             </a:pPr>
             <a:r>
-              <a:rPr sz="1600" b="1">
+              <a:rPr sz="1500" b="1">
                 <a:solidFill>
                   <a:srgbClr val="1A232F"/>
                 </a:solidFill>
                 <a:latin typeface="Apple SD Gothic Neo"/>
               </a:rPr>
-              <a:t>✓ 9-setting summary gain
-✓ prior–residual 역할 분리
-✓ executor 효과의 반례
-✓ test 전 route 동결</a:t>
-            </a:r>
-          </a:p>
-        </p:txBody>
-      </p:sp>
-      <p:sp>
-        <p:nvSpPr>
-          <p:cNvPr id="9" name="Rounded Rectangle 8"/>
+              <a:t>해석 제한</a:t>
+            </a:r>
+          </a:p>
+        </p:txBody>
+      </p:sp>
+      <p:sp>
+        <p:nvSpPr>
+          <p:cNvPr id="25" name="TextBox 24"/>
+          <p:cNvSpPr txBox="1"/>
+          <p:nvPr/>
+        </p:nvSpPr>
+        <p:spPr>
+          <a:xfrm>
+            <a:off x="2743200" y="4690872"/>
+            <a:ext cx="8046720" cy="731520"/>
+          </a:xfrm>
+          <a:prstGeom prst="rect">
+            <a:avLst/>
+          </a:prstGeom>
+          <a:noFill/>
+        </p:spPr>
+        <p:txBody>
+          <a:bodyPr wrap="square" anchor="ctr">
+            <a:spAutoFit/>
+          </a:bodyPr>
+          <a:lstStyle/>
+          <a:p>
+            <a:pPr algn="l">
+              <a:spcAft>
+                <a:spcPts val="0"/>
+              </a:spcAft>
+            </a:pPr>
+            <a:r>
+              <a:rPr sz="1250" b="1">
+                <a:solidFill>
+                  <a:srgbClr val="5B6777"/>
+                </a:solidFill>
+                <a:latin typeface="Apple SD Gothic Neo"/>
+              </a:rPr>
+              <a:t>5 seeds는 독립 cohort가 아님 · NASA/N-CMAPSS unit 수가 작음
+retrospective split은 prospective 확증을 대체하지 않음</a:t>
+            </a:r>
+          </a:p>
+        </p:txBody>
+      </p:sp>
+      <p:sp>
+        <p:nvSpPr>
+          <p:cNvPr id="26" name="Rounded Rectangle 25"/>
           <p:cNvSpPr/>
           <p:nvPr/>
         </p:nvSpPr>
         <p:spPr>
           <a:xfrm>
-            <a:off x="6272784" y="1325880"/>
-            <a:ext cx="5257800" cy="4434840"/>
+            <a:off x="822960" y="5715000"/>
+            <a:ext cx="10698480" cy="502920"/>
           </a:xfrm>
           <a:prstGeom prst="roundRect">
             <a:avLst/>
@@ -6359,81 +6424,39 @@
       </p:sp>
       <p:sp>
         <p:nvSpPr>
-          <p:cNvPr id="10" name="TextBox 9"/>
-          <p:cNvSpPr txBox="1"/>
-          <p:nvPr/>
-        </p:nvSpPr>
-        <p:spPr>
-          <a:xfrm>
-            <a:off x="6574536" y="1600200"/>
-            <a:ext cx="4663440" cy="411480"/>
-          </a:xfrm>
-          <a:prstGeom prst="rect">
-            <a:avLst/>
-          </a:prstGeom>
-          <a:noFill/>
-        </p:spPr>
-        <p:txBody>
-          <a:bodyPr wrap="square" anchor="ctr">
-            <a:spAutoFit/>
-          </a:bodyPr>
-          <a:lstStyle/>
-          <a:p>
-            <a:pPr algn="l">
-              <a:spcAft>
-                <a:spcPts val="0"/>
-              </a:spcAft>
-            </a:pPr>
-            <a:r>
-              <a:rPr sz="2100" b="1">
+          <p:cNvPr id="27" name="TextBox 26"/>
+          <p:cNvSpPr txBox="1"/>
+          <p:nvPr/>
+        </p:nvSpPr>
+        <p:spPr>
+          <a:xfrm>
+            <a:off x="1051560" y="5769864"/>
+            <a:ext cx="10241280" cy="384048"/>
+          </a:xfrm>
+          <a:prstGeom prst="rect">
+            <a:avLst/>
+          </a:prstGeom>
+          <a:noFill/>
+        </p:spPr>
+        <p:txBody>
+          <a:bodyPr wrap="square" anchor="ctr">
+            <a:spAutoFit/>
+          </a:bodyPr>
+          <a:lstStyle/>
+          <a:p>
+            <a:pPr algn="ctr">
+              <a:spcAft>
+                <a:spcPts val="0"/>
+              </a:spcAft>
+            </a:pPr>
+            <a:r>
+              <a:rPr sz="1200" b="1">
                 <a:solidFill>
                   <a:srgbClr val="BE4141"/>
                 </a:solidFill>
                 <a:latin typeface="Apple SD Gothic Neo"/>
               </a:rPr>
-              <a:t>말하면 안 됨</a:t>
-            </a:r>
-          </a:p>
-        </p:txBody>
-      </p:sp>
-      <p:sp>
-        <p:nvSpPr>
-          <p:cNvPr id="11" name="TextBox 10"/>
-          <p:cNvSpPr txBox="1"/>
-          <p:nvPr/>
-        </p:nvSpPr>
-        <p:spPr>
-          <a:xfrm>
-            <a:off x="6574536" y="2304288"/>
-            <a:ext cx="4617720" cy="2560320"/>
-          </a:xfrm>
-          <a:prstGeom prst="rect">
-            <a:avLst/>
-          </a:prstGeom>
-          <a:noFill/>
-        </p:spPr>
-        <p:txBody>
-          <a:bodyPr wrap="square" anchor="ctr">
-            <a:spAutoFit/>
-          </a:bodyPr>
-          <a:lstStyle/>
-          <a:p>
-            <a:pPr algn="l">
-              <a:spcAft>
-                <a:spcPts val="0"/>
-              </a:spcAft>
-            </a:pPr>
-            <a:r>
-              <a:rPr sz="1600" b="1">
-                <a:solidFill>
-                  <a:srgbClr val="1A232F"/>
-                </a:solidFill>
-                <a:latin typeface="Apple SD Gothic Neo"/>
-              </a:rPr>
-              <a:t>× 모든 데이터에서 SOTA
-× OOF mode-stability가 Final에서 실행됨
-× 모든 executor가 항상 유효
-× 미래 cohort 성능 보장</a:t>
+              <a:t>FEMTO v1_declared abstention은 Final BH family에서 제외</a:t>
             </a:r>
           </a:p>
         </p:txBody>
@@ -6447,6 +6470,436 @@
 </file>
 
 <file path=ppt/slides/slide16.xml><?xml version="1.0" encoding="utf-8"?>
+<p:sld xmlns:a="http://schemas.openxmlformats.org/drawingml/2006/main" xmlns:p="http://schemas.openxmlformats.org/presentationml/2006/main" xmlns:r="http://schemas.openxmlformats.org/officeDocument/2006/relationships">
+  <p:cSld>
+    <p:bg>
+      <p:bgPr>
+        <a:solidFill>
+          <a:srgbClr val="FFFFFF"/>
+        </a:solidFill>
+        <a:effectLst/>
+      </p:bgPr>
+    </p:bg>
+    <p:spTree>
+      <p:nvGrpSpPr>
+        <p:cNvPr id="1" name=""/>
+        <p:cNvGrpSpPr/>
+        <p:nvPr/>
+      </p:nvGrpSpPr>
+      <p:grpSpPr/>
+      <p:sp>
+        <p:nvSpPr>
+          <p:cNvPr id="2" name="TextBox 1"/>
+          <p:cNvSpPr txBox="1"/>
+          <p:nvPr/>
+        </p:nvSpPr>
+        <p:spPr>
+          <a:xfrm>
+            <a:off x="502920" y="228600"/>
+            <a:ext cx="10789920" cy="411480"/>
+          </a:xfrm>
+          <a:prstGeom prst="rect">
+            <a:avLst/>
+          </a:prstGeom>
+          <a:noFill/>
+        </p:spPr>
+        <p:txBody>
+          <a:bodyPr wrap="square" anchor="ctr">
+            <a:spAutoFit/>
+          </a:bodyPr>
+          <a:lstStyle/>
+          <a:p>
+            <a:pPr algn="l">
+              <a:spcAft>
+                <a:spcPts val="0"/>
+              </a:spcAft>
+            </a:pPr>
+            <a:r>
+              <a:rPr sz="2500" b="1">
+                <a:solidFill>
+                  <a:srgbClr val="1A232F"/>
+                </a:solidFill>
+                <a:latin typeface="Apple SD Gothic Neo"/>
+              </a:rPr>
+              <a:t>무엇을 주장하고, 무엇을 주장하지 않는가</a:t>
+            </a:r>
+          </a:p>
+        </p:txBody>
+      </p:sp>
+      <p:sp>
+        <p:nvSpPr>
+          <p:cNvPr id="3" name="TextBox 2"/>
+          <p:cNvSpPr txBox="1"/>
+          <p:nvPr/>
+        </p:nvSpPr>
+        <p:spPr>
+          <a:xfrm>
+            <a:off x="530352" y="658368"/>
+            <a:ext cx="10698480" cy="256032"/>
+          </a:xfrm>
+          <a:prstGeom prst="rect">
+            <a:avLst/>
+          </a:prstGeom>
+          <a:noFill/>
+        </p:spPr>
+        <p:txBody>
+          <a:bodyPr wrap="square" anchor="ctr">
+            <a:spAutoFit/>
+          </a:bodyPr>
+          <a:lstStyle/>
+          <a:p>
+            <a:pPr algn="l">
+              <a:spcAft>
+                <a:spcPts val="0"/>
+              </a:spcAft>
+            </a:pPr>
+            <a:r>
+              <a:rPr sz="1050" b="0">
+                <a:solidFill>
+                  <a:srgbClr val="5B6777"/>
+                </a:solidFill>
+                <a:latin typeface="Apple SD Gothic Neo"/>
+              </a:rPr>
+              <a:t>성과보다 실행 계약의 범위를 먼저 고정한다.</a:t>
+            </a:r>
+          </a:p>
+        </p:txBody>
+      </p:sp>
+      <p:sp>
+        <p:nvSpPr>
+          <p:cNvPr id="4" name="TextBox 3"/>
+          <p:cNvSpPr txBox="1"/>
+          <p:nvPr/>
+        </p:nvSpPr>
+        <p:spPr>
+          <a:xfrm>
+            <a:off x="11201400" y="292608"/>
+            <a:ext cx="457200" cy="274320"/>
+          </a:xfrm>
+          <a:prstGeom prst="rect">
+            <a:avLst/>
+          </a:prstGeom>
+          <a:noFill/>
+        </p:spPr>
+        <p:txBody>
+          <a:bodyPr wrap="square" anchor="ctr">
+            <a:spAutoFit/>
+          </a:bodyPr>
+          <a:lstStyle/>
+          <a:p>
+            <a:pPr algn="r">
+              <a:spcAft>
+                <a:spcPts val="0"/>
+              </a:spcAft>
+            </a:pPr>
+            <a:r>
+              <a:rPr sz="1000" b="1">
+                <a:solidFill>
+                  <a:srgbClr val="5B6777"/>
+                </a:solidFill>
+                <a:latin typeface="Apple SD Gothic Neo"/>
+              </a:rPr>
+              <a:t>16</a:t>
+            </a:r>
+          </a:p>
+        </p:txBody>
+      </p:sp>
+      <p:cxnSp>
+        <p:nvCxnSpPr>
+          <p:cNvPr id="5" name="Connector 4"/>
+          <p:cNvCxnSpPr/>
+          <p:nvPr/>
+        </p:nvCxnSpPr>
+        <p:spPr>
+          <a:xfrm>
+            <a:off x="502920" y="987552"/>
+            <a:ext cx="11183112" cy="0"/>
+          </a:xfrm>
+          <a:prstGeom prst="line">
+            <a:avLst/>
+          </a:prstGeom>
+          <a:ln w="12700">
+            <a:solidFill>
+              <a:srgbClr val="DFE3E8"/>
+            </a:solidFill>
+          </a:ln>
+        </p:spPr>
+        <p:style>
+          <a:lnRef idx="2">
+            <a:schemeClr val="accent1"/>
+          </a:lnRef>
+          <a:fillRef idx="0">
+            <a:schemeClr val="accent1"/>
+          </a:fillRef>
+          <a:effectRef idx="1">
+            <a:schemeClr val="accent1"/>
+          </a:effectRef>
+          <a:fontRef idx="minor">
+            <a:schemeClr val="tx1"/>
+          </a:fontRef>
+        </p:style>
+      </p:cxnSp>
+      <p:sp>
+        <p:nvSpPr>
+          <p:cNvPr id="6" name="Rounded Rectangle 5"/>
+          <p:cNvSpPr/>
+          <p:nvPr/>
+        </p:nvSpPr>
+        <p:spPr>
+          <a:xfrm>
+            <a:off x="658368" y="1325880"/>
+            <a:ext cx="5257800" cy="4434840"/>
+          </a:xfrm>
+          <a:prstGeom prst="roundRect">
+            <a:avLst/>
+          </a:prstGeom>
+          <a:solidFill>
+            <a:srgbClr val="E7F6EF"/>
+          </a:solidFill>
+          <a:ln w="15240">
+            <a:solidFill>
+              <a:srgbClr val="2D9168"/>
+            </a:solidFill>
+          </a:ln>
+        </p:spPr>
+        <p:style>
+          <a:lnRef idx="1">
+            <a:schemeClr val="accent1"/>
+          </a:lnRef>
+          <a:fillRef idx="3">
+            <a:schemeClr val="accent1"/>
+          </a:fillRef>
+          <a:effectRef idx="2">
+            <a:schemeClr val="accent1"/>
+          </a:effectRef>
+          <a:fontRef idx="minor">
+            <a:schemeClr val="lt1"/>
+          </a:fontRef>
+        </p:style>
+        <p:txBody>
+          <a:bodyPr rtlCol="0" anchor="ctr"/>
+          <a:lstStyle/>
+          <a:p>
+            <a:pPr algn="ctr"/>
+          </a:p>
+        </p:txBody>
+      </p:sp>
+      <p:sp>
+        <p:nvSpPr>
+          <p:cNvPr id="7" name="TextBox 6"/>
+          <p:cNvSpPr txBox="1"/>
+          <p:nvPr/>
+        </p:nvSpPr>
+        <p:spPr>
+          <a:xfrm>
+            <a:off x="960120" y="1600200"/>
+            <a:ext cx="4663440" cy="411480"/>
+          </a:xfrm>
+          <a:prstGeom prst="rect">
+            <a:avLst/>
+          </a:prstGeom>
+          <a:noFill/>
+        </p:spPr>
+        <p:txBody>
+          <a:bodyPr wrap="square" anchor="ctr">
+            <a:spAutoFit/>
+          </a:bodyPr>
+          <a:lstStyle/>
+          <a:p>
+            <a:pPr algn="l">
+              <a:spcAft>
+                <a:spcPts val="0"/>
+              </a:spcAft>
+            </a:pPr>
+            <a:r>
+              <a:rPr sz="2100" b="1">
+                <a:solidFill>
+                  <a:srgbClr val="2D9168"/>
+                </a:solidFill>
+                <a:latin typeface="Apple SD Gothic Neo"/>
+              </a:rPr>
+              <a:t>말할 수 있음</a:t>
+            </a:r>
+          </a:p>
+        </p:txBody>
+      </p:sp>
+      <p:sp>
+        <p:nvSpPr>
+          <p:cNvPr id="8" name="TextBox 7"/>
+          <p:cNvSpPr txBox="1"/>
+          <p:nvPr/>
+        </p:nvSpPr>
+        <p:spPr>
+          <a:xfrm>
+            <a:off x="960120" y="2304288"/>
+            <a:ext cx="4617720" cy="2560320"/>
+          </a:xfrm>
+          <a:prstGeom prst="rect">
+            <a:avLst/>
+          </a:prstGeom>
+          <a:noFill/>
+        </p:spPr>
+        <p:txBody>
+          <a:bodyPr wrap="square" anchor="ctr">
+            <a:spAutoFit/>
+          </a:bodyPr>
+          <a:lstStyle/>
+          <a:p>
+            <a:pPr algn="l">
+              <a:spcAft>
+                <a:spcPts val="0"/>
+              </a:spcAft>
+            </a:pPr>
+            <a:r>
+              <a:rPr sz="1600" b="1">
+                <a:solidFill>
+                  <a:srgbClr val="1A232F"/>
+                </a:solidFill>
+                <a:latin typeface="Apple SD Gothic Neo"/>
+              </a:rPr>
+              <a:t>✓ 9-setting summary gain
+✓ prior–residual 역할 분리
+✓ executor 효과의 반례
+✓ test 전 route 동결</a:t>
+            </a:r>
+          </a:p>
+        </p:txBody>
+      </p:sp>
+      <p:sp>
+        <p:nvSpPr>
+          <p:cNvPr id="9" name="Rounded Rectangle 8"/>
+          <p:cNvSpPr/>
+          <p:nvPr/>
+        </p:nvSpPr>
+        <p:spPr>
+          <a:xfrm>
+            <a:off x="6272784" y="1325880"/>
+            <a:ext cx="5257800" cy="4434840"/>
+          </a:xfrm>
+          <a:prstGeom prst="roundRect">
+            <a:avLst/>
+          </a:prstGeom>
+          <a:solidFill>
+            <a:srgbClr val="FBEBEB"/>
+          </a:solidFill>
+          <a:ln w="15240">
+            <a:solidFill>
+              <a:srgbClr val="BE4141"/>
+            </a:solidFill>
+          </a:ln>
+        </p:spPr>
+        <p:style>
+          <a:lnRef idx="1">
+            <a:schemeClr val="accent1"/>
+          </a:lnRef>
+          <a:fillRef idx="3">
+            <a:schemeClr val="accent1"/>
+          </a:fillRef>
+          <a:effectRef idx="2">
+            <a:schemeClr val="accent1"/>
+          </a:effectRef>
+          <a:fontRef idx="minor">
+            <a:schemeClr val="lt1"/>
+          </a:fontRef>
+        </p:style>
+        <p:txBody>
+          <a:bodyPr rtlCol="0" anchor="ctr"/>
+          <a:lstStyle/>
+          <a:p>
+            <a:pPr algn="ctr"/>
+          </a:p>
+        </p:txBody>
+      </p:sp>
+      <p:sp>
+        <p:nvSpPr>
+          <p:cNvPr id="10" name="TextBox 9"/>
+          <p:cNvSpPr txBox="1"/>
+          <p:nvPr/>
+        </p:nvSpPr>
+        <p:spPr>
+          <a:xfrm>
+            <a:off x="6574536" y="1600200"/>
+            <a:ext cx="4663440" cy="411480"/>
+          </a:xfrm>
+          <a:prstGeom prst="rect">
+            <a:avLst/>
+          </a:prstGeom>
+          <a:noFill/>
+        </p:spPr>
+        <p:txBody>
+          <a:bodyPr wrap="square" anchor="ctr">
+            <a:spAutoFit/>
+          </a:bodyPr>
+          <a:lstStyle/>
+          <a:p>
+            <a:pPr algn="l">
+              <a:spcAft>
+                <a:spcPts val="0"/>
+              </a:spcAft>
+            </a:pPr>
+            <a:r>
+              <a:rPr sz="2100" b="1">
+                <a:solidFill>
+                  <a:srgbClr val="BE4141"/>
+                </a:solidFill>
+                <a:latin typeface="Apple SD Gothic Neo"/>
+              </a:rPr>
+              <a:t>말하면 안 됨</a:t>
+            </a:r>
+          </a:p>
+        </p:txBody>
+      </p:sp>
+      <p:sp>
+        <p:nvSpPr>
+          <p:cNvPr id="11" name="TextBox 10"/>
+          <p:cNvSpPr txBox="1"/>
+          <p:nvPr/>
+        </p:nvSpPr>
+        <p:spPr>
+          <a:xfrm>
+            <a:off x="6574536" y="2304288"/>
+            <a:ext cx="4617720" cy="2560320"/>
+          </a:xfrm>
+          <a:prstGeom prst="rect">
+            <a:avLst/>
+          </a:prstGeom>
+          <a:noFill/>
+        </p:spPr>
+        <p:txBody>
+          <a:bodyPr wrap="square" anchor="ctr">
+            <a:spAutoFit/>
+          </a:bodyPr>
+          <a:lstStyle/>
+          <a:p>
+            <a:pPr algn="l">
+              <a:spcAft>
+                <a:spcPts val="0"/>
+              </a:spcAft>
+            </a:pPr>
+            <a:r>
+              <a:rPr sz="1600" b="1">
+                <a:solidFill>
+                  <a:srgbClr val="1A232F"/>
+                </a:solidFill>
+                <a:latin typeface="Apple SD Gothic Neo"/>
+              </a:rPr>
+              <a:t>× 모든 데이터에서 SOTA
+× OOF mode-stability가 Final에서 실행됨
+× 모든 executor가 항상 유효
+× 미래 cohort 성능 보장</a:t>
+            </a:r>
+          </a:p>
+        </p:txBody>
+      </p:sp>
+    </p:spTree>
+  </p:cSld>
+  <p:clrMapOvr>
+    <a:masterClrMapping/>
+  </p:clrMapOvr>
+</p:sld>
+</file>
+
+<file path=ppt/slides/slide17.xml><?xml version="1.0" encoding="utf-8"?>
 <p:sld xmlns:a="http://schemas.openxmlformats.org/drawingml/2006/main" xmlns:p="http://schemas.openxmlformats.org/presentationml/2006/main" xmlns:r="http://schemas.openxmlformats.org/officeDocument/2006/relationships">
   <p:cSld>
     <p:bg>
@@ -7375,7 +7828,7 @@
                 </a:solidFill>
                 <a:latin typeface="Apple SD Gothic Neo"/>
               </a:rPr>
-              <a:t>16 / 16</a:t>
+              <a:t>17 / 17</a:t>
             </a:r>
           </a:p>
         </p:txBody>

</xml_diff>

<commit_message>
Clarify PP-X statistical test purposes in talk
Co-authored-by: Cursor <cursoragent@cursor.com>
</commit_message>
<xml_diff>
--- a/ppt/PP-X_Final_Visual_Talk_20min.pptx
+++ b/ppt/PP-X_Final_Visual_Talk_20min.pptx
@@ -22,6 +22,7 @@
     <p:sldId id="270" r:id="rId21"/>
     <p:sldId id="271" r:id="rId22"/>
     <p:sldId id="272" r:id="rId23"/>
+    <p:sldId id="273" r:id="rId24"/>
   </p:sldIdLst>
   <p:sldSz cx="12191695" cy="6858000" type="screen4x3"/>
   <p:notesSz cx="6858000" cy="9144000"/>
@@ -3422,7 +3423,7 @@
                 </a:solidFill>
                 <a:latin typeface="Apple SD Gothic Neo"/>
               </a:rPr>
-              <a:t>01 / 17</a:t>
+              <a:t>01 / 18</a:t>
             </a:r>
           </a:p>
         </p:txBody>
@@ -5442,7 +5443,7 @@
                 </a:solidFill>
                 <a:latin typeface="Apple SD Gothic Neo"/>
               </a:rPr>
-              <a:t>통계검정 — 행이 아니라 물리 unit이 표본</a:t>
+              <a:t>검정 1 — prior–residual 구조가 실제로 필요한가</a:t>
             </a:r>
           </a:p>
         </p:txBody>
@@ -5481,7 +5482,7 @@
                 </a:solidFill>
                 <a:latin typeface="Apple SD Gothic Neo"/>
               </a:rPr>
-              <a:t>요약 효과와 개별 component evidence를 분리한다.</a:t>
+              <a:t>경쟁모델 순위가 아니라, PP-X 내부 구조의 효과를 묻는 검정</a:t>
             </a:r>
           </a:p>
         </p:txBody>
@@ -5568,8 +5569,8 @@
         </p:nvSpPr>
         <p:spPr>
           <a:xfrm>
-            <a:off x="685800" y="1417320"/>
-            <a:ext cx="2194560" cy="1828800"/>
+            <a:off x="640080" y="1261872"/>
+            <a:ext cx="3520440" cy="4526280"/>
           </a:xfrm>
           <a:prstGeom prst="roundRect">
             <a:avLst/>
@@ -5613,8 +5614,47 @@
         </p:nvSpPr>
         <p:spPr>
           <a:xfrm>
-            <a:off x="685800" y="1664208"/>
-            <a:ext cx="2194560" cy="548640"/>
+            <a:off x="914400" y="1527048"/>
+            <a:ext cx="2971800" cy="384048"/>
+          </a:xfrm>
+          <a:prstGeom prst="rect">
+            <a:avLst/>
+          </a:prstGeom>
+          <a:noFill/>
+        </p:spPr>
+        <p:txBody>
+          <a:bodyPr wrap="square" anchor="ctr">
+            <a:spAutoFit/>
+          </a:bodyPr>
+          <a:lstStyle/>
+          <a:p>
+            <a:pPr algn="l">
+              <a:spcAft>
+                <a:spcPts val="0"/>
+              </a:spcAft>
+            </a:pPr>
+            <a:r>
+              <a:rPr sz="1800" b="1">
+                <a:solidFill>
+                  <a:srgbClr val="1F6BB5"/>
+                </a:solidFill>
+                <a:latin typeface="Apple SD Gothic Neo"/>
+              </a:rPr>
+              <a:t>무엇과 비교했나</a:t>
+            </a:r>
+          </a:p>
+        </p:txBody>
+      </p:sp>
+      <p:sp>
+        <p:nvSpPr>
+          <p:cNvPr id="8" name="TextBox 7"/>
+          <p:cNvSpPr txBox="1"/>
+          <p:nvPr/>
+        </p:nvSpPr>
+        <p:spPr>
+          <a:xfrm>
+            <a:off x="914400" y="2121408"/>
+            <a:ext cx="2971800" cy="1325880"/>
           </a:xfrm>
           <a:prstGeom prst="rect">
             <a:avLst/>
@@ -5633,27 +5673,29 @@
               </a:spcAft>
             </a:pPr>
             <a:r>
-              <a:rPr sz="2200" b="1">
-                <a:solidFill>
-                  <a:srgbClr val="1F6BB5"/>
-                </a:solidFill>
-                <a:latin typeface="Apple SD Gothic Neo"/>
-              </a:rPr>
-              <a:t>9 / 9</a:t>
-            </a:r>
-          </a:p>
-        </p:txBody>
-      </p:sp>
-      <p:sp>
-        <p:nvSpPr>
-          <p:cNvPr id="8" name="TextBox 7"/>
-          <p:cNvSpPr txBox="1"/>
-          <p:nvPr/>
-        </p:nvSpPr>
-        <p:spPr>
-          <a:xfrm>
-            <a:off x="685800" y="2359152"/>
-            <a:ext cx="2194560" cy="594360"/>
+              <a:rPr sz="2100" b="1">
+                <a:solidFill>
+                  <a:srgbClr val="1A232F"/>
+                </a:solidFill>
+                <a:latin typeface="Apple SD Gothic Neo"/>
+              </a:rPr>
+              <a:t>PP-X Final
+vs
+matched direct</a:t>
+            </a:r>
+          </a:p>
+        </p:txBody>
+      </p:sp>
+      <p:sp>
+        <p:nvSpPr>
+          <p:cNvPr id="9" name="TextBox 8"/>
+          <p:cNvSpPr txBox="1"/>
+          <p:nvPr/>
+        </p:nvSpPr>
+        <p:spPr>
+          <a:xfrm>
+            <a:off x="914400" y="3703320"/>
+            <a:ext cx="2971800" cy="1371600"/>
           </a:xfrm>
           <a:prstGeom prst="rect">
             <a:avLst/>
@@ -5672,28 +5714,113 @@
               </a:spcAft>
             </a:pPr>
             <a:r>
-              <a:rPr sz="1150" b="1">
-                <a:solidFill>
-                  <a:srgbClr val="1A232F"/>
-                </a:solidFill>
-                <a:latin typeface="Apple SD Gothic Neo"/>
-              </a:rPr>
-              <a:t>vs matched direct
-방향 일치</a:t>
-            </a:r>
-          </a:p>
-        </p:txBody>
-      </p:sp>
-      <p:sp>
-        <p:nvSpPr>
-          <p:cNvPr id="9" name="Rounded Rectangle 8"/>
+              <a:rPr sz="1250" b="1">
+                <a:solidFill>
+                  <a:srgbClr val="5B6777"/>
+                </a:solidFill>
+                <a:latin typeface="Apple SD Gothic Neo"/>
+              </a:rPr>
+              <a:t>matched direct = 같은 데이터·split에서
+BQ/affine prior 구조를 제거하고
+RUL을 직접 예측한 내부 대조군</a:t>
+            </a:r>
+          </a:p>
+        </p:txBody>
+      </p:sp>
+      <p:sp>
+        <p:nvSpPr>
+          <p:cNvPr id="10" name="Rounded Rectangle 9"/>
           <p:cNvSpPr/>
           <p:nvPr/>
         </p:nvSpPr>
         <p:spPr>
           <a:xfrm>
-            <a:off x="3566160" y="1417320"/>
-            <a:ext cx="2194560" cy="1828800"/>
+            <a:off x="1325880" y="5212080"/>
+            <a:ext cx="2148840" cy="329184"/>
+          </a:xfrm>
+          <a:prstGeom prst="roundRect">
+            <a:avLst/>
+          </a:prstGeom>
+          <a:solidFill>
+            <a:srgbClr val="BE4141"/>
+          </a:solidFill>
+          <a:ln w="15240">
+            <a:solidFill>
+              <a:srgbClr val="BE4141"/>
+            </a:solidFill>
+          </a:ln>
+        </p:spPr>
+        <p:style>
+          <a:lnRef idx="1">
+            <a:schemeClr val="accent1"/>
+          </a:lnRef>
+          <a:fillRef idx="3">
+            <a:schemeClr val="accent1"/>
+          </a:fillRef>
+          <a:effectRef idx="2">
+            <a:schemeClr val="accent1"/>
+          </a:effectRef>
+          <a:fontRef idx="minor">
+            <a:schemeClr val="lt1"/>
+          </a:fontRef>
+        </p:style>
+        <p:txBody>
+          <a:bodyPr rtlCol="0" anchor="ctr"/>
+          <a:lstStyle/>
+          <a:p>
+            <a:pPr algn="ctr"/>
+          </a:p>
+        </p:txBody>
+      </p:sp>
+      <p:sp>
+        <p:nvSpPr>
+          <p:cNvPr id="11" name="TextBox 10"/>
+          <p:cNvSpPr txBox="1"/>
+          <p:nvPr/>
+        </p:nvSpPr>
+        <p:spPr>
+          <a:xfrm>
+            <a:off x="1325880" y="5212080"/>
+            <a:ext cx="2148840" cy="329184"/>
+          </a:xfrm>
+          <a:prstGeom prst="rect">
+            <a:avLst/>
+          </a:prstGeom>
+          <a:noFill/>
+        </p:spPr>
+        <p:txBody>
+          <a:bodyPr wrap="square" anchor="ctr">
+            <a:spAutoFit/>
+          </a:bodyPr>
+          <a:lstStyle/>
+          <a:p>
+            <a:pPr algn="ctr">
+              <a:spcAft>
+                <a:spcPts val="0"/>
+              </a:spcAft>
+            </a:pPr>
+            <a:r>
+              <a:rPr sz="1100" b="1">
+                <a:solidFill>
+                  <a:srgbClr val="FFFFFF"/>
+                </a:solidFill>
+                <a:latin typeface="Apple SD Gothic Neo"/>
+              </a:rPr>
+              <a:t>FT-Transformer 아님</a:t>
+            </a:r>
+          </a:p>
+        </p:txBody>
+      </p:sp>
+      <p:sp>
+        <p:nvSpPr>
+          <p:cNvPr id="12" name="Rounded Rectangle 11"/>
+          <p:cNvSpPr/>
+          <p:nvPr/>
+        </p:nvSpPr>
+        <p:spPr>
+          <a:xfrm>
+            <a:off x="4389120" y="1261872"/>
+            <a:ext cx="3429000" cy="4526280"/>
           </a:xfrm>
           <a:prstGeom prst="roundRect">
             <a:avLst/>
@@ -5731,14 +5858,96 @@
       </p:sp>
       <p:sp>
         <p:nvSpPr>
-          <p:cNvPr id="10" name="TextBox 9"/>
-          <p:cNvSpPr txBox="1"/>
-          <p:nvPr/>
-        </p:nvSpPr>
-        <p:spPr>
-          <a:xfrm>
-            <a:off x="3566160" y="1664208"/>
-            <a:ext cx="2194560" cy="548640"/>
+          <p:cNvPr id="13" name="TextBox 12"/>
+          <p:cNvSpPr txBox="1"/>
+          <p:nvPr/>
+        </p:nvSpPr>
+        <p:spPr>
+          <a:xfrm>
+            <a:off x="4663440" y="1527048"/>
+            <a:ext cx="2880360" cy="384048"/>
+          </a:xfrm>
+          <a:prstGeom prst="rect">
+            <a:avLst/>
+          </a:prstGeom>
+          <a:noFill/>
+        </p:spPr>
+        <p:txBody>
+          <a:bodyPr wrap="square" anchor="ctr">
+            <a:spAutoFit/>
+          </a:bodyPr>
+          <a:lstStyle/>
+          <a:p>
+            <a:pPr algn="l">
+              <a:spcAft>
+                <a:spcPts val="0"/>
+              </a:spcAft>
+            </a:pPr>
+            <a:r>
+              <a:rPr sz="1800" b="1">
+                <a:solidFill>
+                  <a:srgbClr val="2D9DB8"/>
+                </a:solidFill>
+                <a:latin typeface="Apple SD Gothic Neo"/>
+              </a:rPr>
+              <a:t>어떻게 검정했나</a:t>
+            </a:r>
+          </a:p>
+        </p:txBody>
+      </p:sp>
+      <p:sp>
+        <p:nvSpPr>
+          <p:cNvPr id="14" name="Oval 13"/>
+          <p:cNvSpPr/>
+          <p:nvPr/>
+        </p:nvSpPr>
+        <p:spPr>
+          <a:xfrm>
+            <a:off x="4645152" y="2084831"/>
+            <a:ext cx="384048" cy="384048"/>
+          </a:xfrm>
+          <a:prstGeom prst="ellipse">
+            <a:avLst/>
+          </a:prstGeom>
+          <a:solidFill>
+            <a:srgbClr val="2D9DB8"/>
+          </a:solidFill>
+          <a:ln>
+            <a:noFill/>
+          </a:ln>
+        </p:spPr>
+        <p:style>
+          <a:lnRef idx="1">
+            <a:schemeClr val="accent1"/>
+          </a:lnRef>
+          <a:fillRef idx="3">
+            <a:schemeClr val="accent1"/>
+          </a:fillRef>
+          <a:effectRef idx="2">
+            <a:schemeClr val="accent1"/>
+          </a:effectRef>
+          <a:fontRef idx="minor">
+            <a:schemeClr val="lt1"/>
+          </a:fontRef>
+        </p:style>
+        <p:txBody>
+          <a:bodyPr rtlCol="0" anchor="ctr"/>
+          <a:lstStyle/>
+          <a:p>
+            <a:pPr algn="ctr"/>
+          </a:p>
+        </p:txBody>
+      </p:sp>
+      <p:sp>
+        <p:nvSpPr>
+          <p:cNvPr id="15" name="TextBox 14"/>
+          <p:cNvSpPr txBox="1"/>
+          <p:nvPr/>
+        </p:nvSpPr>
+        <p:spPr>
+          <a:xfrm>
+            <a:off x="4645152" y="2084831"/>
+            <a:ext cx="384048" cy="384048"/>
           </a:xfrm>
           <a:prstGeom prst="rect">
             <a:avLst/>
@@ -5757,27 +5966,109 @@
               </a:spcAft>
             </a:pPr>
             <a:r>
-              <a:rPr sz="2200" b="1">
-                <a:solidFill>
-                  <a:srgbClr val="2D9DB8"/>
-                </a:solidFill>
-                <a:latin typeface="Apple SD Gothic Neo"/>
-              </a:rPr>
-              <a:t>p = .0039</a:t>
-            </a:r>
-          </a:p>
-        </p:txBody>
-      </p:sp>
-      <p:sp>
-        <p:nvSpPr>
-          <p:cNvPr id="11" name="TextBox 10"/>
-          <p:cNvSpPr txBox="1"/>
-          <p:nvPr/>
-        </p:nvSpPr>
-        <p:spPr>
-          <a:xfrm>
-            <a:off x="3566160" y="2359152"/>
-            <a:ext cx="2194560" cy="594360"/>
+              <a:rPr sz="1050" b="1">
+                <a:solidFill>
+                  <a:srgbClr val="FFFFFF"/>
+                </a:solidFill>
+                <a:latin typeface="Apple SD Gothic Neo"/>
+              </a:rPr>
+              <a:t>①</a:t>
+            </a:r>
+          </a:p>
+        </p:txBody>
+      </p:sp>
+      <p:sp>
+        <p:nvSpPr>
+          <p:cNvPr id="16" name="TextBox 15"/>
+          <p:cNvSpPr txBox="1"/>
+          <p:nvPr/>
+        </p:nvSpPr>
+        <p:spPr>
+          <a:xfrm>
+            <a:off x="5157216" y="2066543"/>
+            <a:ext cx="2331720" cy="420624"/>
+          </a:xfrm>
+          <a:prstGeom prst="rect">
+            <a:avLst/>
+          </a:prstGeom>
+          <a:noFill/>
+        </p:spPr>
+        <p:txBody>
+          <a:bodyPr wrap="square" anchor="ctr">
+            <a:spAutoFit/>
+          </a:bodyPr>
+          <a:lstStyle/>
+          <a:p>
+            <a:pPr algn="l">
+              <a:spcAft>
+                <a:spcPts val="0"/>
+              </a:spcAft>
+            </a:pPr>
+            <a:r>
+              <a:rPr sz="1150" b="1">
+                <a:solidFill>
+                  <a:srgbClr val="1A232F"/>
+                </a:solidFill>
+                <a:latin typeface="Apple SD Gothic Neo"/>
+              </a:rPr>
+              <a:t>각 물리 unit의 RMSE 비교</a:t>
+            </a:r>
+          </a:p>
+        </p:txBody>
+      </p:sp>
+      <p:sp>
+        <p:nvSpPr>
+          <p:cNvPr id="17" name="Oval 16"/>
+          <p:cNvSpPr/>
+          <p:nvPr/>
+        </p:nvSpPr>
+        <p:spPr>
+          <a:xfrm>
+            <a:off x="4645152" y="2798063"/>
+            <a:ext cx="384048" cy="384048"/>
+          </a:xfrm>
+          <a:prstGeom prst="ellipse">
+            <a:avLst/>
+          </a:prstGeom>
+          <a:solidFill>
+            <a:srgbClr val="2D9DB8"/>
+          </a:solidFill>
+          <a:ln>
+            <a:noFill/>
+          </a:ln>
+        </p:spPr>
+        <p:style>
+          <a:lnRef idx="1">
+            <a:schemeClr val="accent1"/>
+          </a:lnRef>
+          <a:fillRef idx="3">
+            <a:schemeClr val="accent1"/>
+          </a:fillRef>
+          <a:effectRef idx="2">
+            <a:schemeClr val="accent1"/>
+          </a:effectRef>
+          <a:fontRef idx="minor">
+            <a:schemeClr val="lt1"/>
+          </a:fontRef>
+        </p:style>
+        <p:txBody>
+          <a:bodyPr rtlCol="0" anchor="ctr"/>
+          <a:lstStyle/>
+          <a:p>
+            <a:pPr algn="ctr"/>
+          </a:p>
+        </p:txBody>
+      </p:sp>
+      <p:sp>
+        <p:nvSpPr>
+          <p:cNvPr id="18" name="TextBox 17"/>
+          <p:cNvSpPr txBox="1"/>
+          <p:nvPr/>
+        </p:nvSpPr>
+        <p:spPr>
+          <a:xfrm>
+            <a:off x="4645152" y="2798063"/>
+            <a:ext cx="384048" cy="384048"/>
           </a:xfrm>
           <a:prstGeom prst="rect">
             <a:avLst/>
@@ -5796,28 +6087,347 @@
               </a:spcAft>
             </a:pPr>
             <a:r>
+              <a:rPr sz="1050" b="1">
+                <a:solidFill>
+                  <a:srgbClr val="FFFFFF"/>
+                </a:solidFill>
+                <a:latin typeface="Apple SD Gothic Neo"/>
+              </a:rPr>
+              <a:t>②</a:t>
+            </a:r>
+          </a:p>
+        </p:txBody>
+      </p:sp>
+      <p:sp>
+        <p:nvSpPr>
+          <p:cNvPr id="19" name="TextBox 18"/>
+          <p:cNvSpPr txBox="1"/>
+          <p:nvPr/>
+        </p:nvSpPr>
+        <p:spPr>
+          <a:xfrm>
+            <a:off x="5157216" y="2779775"/>
+            <a:ext cx="2331720" cy="420624"/>
+          </a:xfrm>
+          <a:prstGeom prst="rect">
+            <a:avLst/>
+          </a:prstGeom>
+          <a:noFill/>
+        </p:spPr>
+        <p:txBody>
+          <a:bodyPr wrap="square" anchor="ctr">
+            <a:spAutoFit/>
+          </a:bodyPr>
+          <a:lstStyle/>
+          <a:p>
+            <a:pPr algn="l">
+              <a:spcAft>
+                <a:spcPts val="0"/>
+              </a:spcAft>
+            </a:pPr>
+            <a:r>
               <a:rPr sz="1150" b="1">
                 <a:solidFill>
                   <a:srgbClr val="1A232F"/>
                 </a:solidFill>
                 <a:latin typeface="Apple SD Gothic Neo"/>
               </a:rPr>
-              <a:t>domain exact
-sign test</a:t>
-            </a:r>
-          </a:p>
-        </p:txBody>
-      </p:sp>
-      <p:sp>
-        <p:nvSpPr>
-          <p:cNvPr id="12" name="Rounded Rectangle 11"/>
+              <a:t>데이터셋 → unit 순서로 재표집</a:t>
+            </a:r>
+          </a:p>
+        </p:txBody>
+      </p:sp>
+      <p:sp>
+        <p:nvSpPr>
+          <p:cNvPr id="20" name="Oval 19"/>
           <p:cNvSpPr/>
           <p:nvPr/>
         </p:nvSpPr>
         <p:spPr>
           <a:xfrm>
-            <a:off x="6446520" y="1417320"/>
-            <a:ext cx="2194560" cy="1828800"/>
+            <a:off x="4645152" y="3511296"/>
+            <a:ext cx="384048" cy="384048"/>
+          </a:xfrm>
+          <a:prstGeom prst="ellipse">
+            <a:avLst/>
+          </a:prstGeom>
+          <a:solidFill>
+            <a:srgbClr val="2D9DB8"/>
+          </a:solidFill>
+          <a:ln>
+            <a:noFill/>
+          </a:ln>
+        </p:spPr>
+        <p:style>
+          <a:lnRef idx="1">
+            <a:schemeClr val="accent1"/>
+          </a:lnRef>
+          <a:fillRef idx="3">
+            <a:schemeClr val="accent1"/>
+          </a:fillRef>
+          <a:effectRef idx="2">
+            <a:schemeClr val="accent1"/>
+          </a:effectRef>
+          <a:fontRef idx="minor">
+            <a:schemeClr val="lt1"/>
+          </a:fontRef>
+        </p:style>
+        <p:txBody>
+          <a:bodyPr rtlCol="0" anchor="ctr"/>
+          <a:lstStyle/>
+          <a:p>
+            <a:pPr algn="ctr"/>
+          </a:p>
+        </p:txBody>
+      </p:sp>
+      <p:sp>
+        <p:nvSpPr>
+          <p:cNvPr id="21" name="TextBox 20"/>
+          <p:cNvSpPr txBox="1"/>
+          <p:nvPr/>
+        </p:nvSpPr>
+        <p:spPr>
+          <a:xfrm>
+            <a:off x="4645152" y="3511296"/>
+            <a:ext cx="384048" cy="384048"/>
+          </a:xfrm>
+          <a:prstGeom prst="rect">
+            <a:avLst/>
+          </a:prstGeom>
+          <a:noFill/>
+        </p:spPr>
+        <p:txBody>
+          <a:bodyPr wrap="square" anchor="ctr">
+            <a:spAutoFit/>
+          </a:bodyPr>
+          <a:lstStyle/>
+          <a:p>
+            <a:pPr algn="ctr">
+              <a:spcAft>
+                <a:spcPts val="0"/>
+              </a:spcAft>
+            </a:pPr>
+            <a:r>
+              <a:rPr sz="1050" b="1">
+                <a:solidFill>
+                  <a:srgbClr val="FFFFFF"/>
+                </a:solidFill>
+                <a:latin typeface="Apple SD Gothic Neo"/>
+              </a:rPr>
+              <a:t>③</a:t>
+            </a:r>
+          </a:p>
+        </p:txBody>
+      </p:sp>
+      <p:sp>
+        <p:nvSpPr>
+          <p:cNvPr id="22" name="TextBox 21"/>
+          <p:cNvSpPr txBox="1"/>
+          <p:nvPr/>
+        </p:nvSpPr>
+        <p:spPr>
+          <a:xfrm>
+            <a:off x="5157216" y="3493008"/>
+            <a:ext cx="2331720" cy="420624"/>
+          </a:xfrm>
+          <a:prstGeom prst="rect">
+            <a:avLst/>
+          </a:prstGeom>
+          <a:noFill/>
+        </p:spPr>
+        <p:txBody>
+          <a:bodyPr wrap="square" anchor="ctr">
+            <a:spAutoFit/>
+          </a:bodyPr>
+          <a:lstStyle/>
+          <a:p>
+            <a:pPr algn="l">
+              <a:spcAft>
+                <a:spcPts val="0"/>
+              </a:spcAft>
+            </a:pPr>
+            <a:r>
+              <a:rPr sz="1150" b="1">
+                <a:solidFill>
+                  <a:srgbClr val="1A232F"/>
+                </a:solidFill>
+                <a:latin typeface="Apple SD Gothic Neo"/>
+              </a:rPr>
+              <a:t>9개 데이터셋을 동일 비중 처리</a:t>
+            </a:r>
+          </a:p>
+        </p:txBody>
+      </p:sp>
+      <p:sp>
+        <p:nvSpPr>
+          <p:cNvPr id="23" name="Oval 22"/>
+          <p:cNvSpPr/>
+          <p:nvPr/>
+        </p:nvSpPr>
+        <p:spPr>
+          <a:xfrm>
+            <a:off x="4645152" y="4224527"/>
+            <a:ext cx="384048" cy="384048"/>
+          </a:xfrm>
+          <a:prstGeom prst="ellipse">
+            <a:avLst/>
+          </a:prstGeom>
+          <a:solidFill>
+            <a:srgbClr val="2D9DB8"/>
+          </a:solidFill>
+          <a:ln>
+            <a:noFill/>
+          </a:ln>
+        </p:spPr>
+        <p:style>
+          <a:lnRef idx="1">
+            <a:schemeClr val="accent1"/>
+          </a:lnRef>
+          <a:fillRef idx="3">
+            <a:schemeClr val="accent1"/>
+          </a:fillRef>
+          <a:effectRef idx="2">
+            <a:schemeClr val="accent1"/>
+          </a:effectRef>
+          <a:fontRef idx="minor">
+            <a:schemeClr val="lt1"/>
+          </a:fontRef>
+        </p:style>
+        <p:txBody>
+          <a:bodyPr rtlCol="0" anchor="ctr"/>
+          <a:lstStyle/>
+          <a:p>
+            <a:pPr algn="ctr"/>
+          </a:p>
+        </p:txBody>
+      </p:sp>
+      <p:sp>
+        <p:nvSpPr>
+          <p:cNvPr id="24" name="TextBox 23"/>
+          <p:cNvSpPr txBox="1"/>
+          <p:nvPr/>
+        </p:nvSpPr>
+        <p:spPr>
+          <a:xfrm>
+            <a:off x="4645152" y="4224527"/>
+            <a:ext cx="384048" cy="384048"/>
+          </a:xfrm>
+          <a:prstGeom prst="rect">
+            <a:avLst/>
+          </a:prstGeom>
+          <a:noFill/>
+        </p:spPr>
+        <p:txBody>
+          <a:bodyPr wrap="square" anchor="ctr">
+            <a:spAutoFit/>
+          </a:bodyPr>
+          <a:lstStyle/>
+          <a:p>
+            <a:pPr algn="ctr">
+              <a:spcAft>
+                <a:spcPts val="0"/>
+              </a:spcAft>
+            </a:pPr>
+            <a:r>
+              <a:rPr sz="1050" b="1">
+                <a:solidFill>
+                  <a:srgbClr val="FFFFFF"/>
+                </a:solidFill>
+                <a:latin typeface="Apple SD Gothic Neo"/>
+              </a:rPr>
+              <a:t>④</a:t>
+            </a:r>
+          </a:p>
+        </p:txBody>
+      </p:sp>
+      <p:sp>
+        <p:nvSpPr>
+          <p:cNvPr id="25" name="TextBox 24"/>
+          <p:cNvSpPr txBox="1"/>
+          <p:nvPr/>
+        </p:nvSpPr>
+        <p:spPr>
+          <a:xfrm>
+            <a:off x="5157216" y="4206240"/>
+            <a:ext cx="2331720" cy="420624"/>
+          </a:xfrm>
+          <a:prstGeom prst="rect">
+            <a:avLst/>
+          </a:prstGeom>
+          <a:noFill/>
+        </p:spPr>
+        <p:txBody>
+          <a:bodyPr wrap="square" anchor="ctr">
+            <a:spAutoFit/>
+          </a:bodyPr>
+          <a:lstStyle/>
+          <a:p>
+            <a:pPr algn="l">
+              <a:spcAft>
+                <a:spcPts val="0"/>
+              </a:spcAft>
+            </a:pPr>
+            <a:r>
+              <a:rPr sz="1150" b="1">
+                <a:solidFill>
+                  <a:srgbClr val="1A232F"/>
+                </a:solidFill>
+                <a:latin typeface="Apple SD Gothic Neo"/>
+              </a:rPr>
+              <a:t>반복마다 RMSE 감소율 계산</a:t>
+            </a:r>
+          </a:p>
+        </p:txBody>
+      </p:sp>
+      <p:sp>
+        <p:nvSpPr>
+          <p:cNvPr id="26" name="TextBox 25"/>
+          <p:cNvSpPr txBox="1"/>
+          <p:nvPr/>
+        </p:nvSpPr>
+        <p:spPr>
+          <a:xfrm>
+            <a:off x="4645152" y="5065776"/>
+            <a:ext cx="2926080" cy="438912"/>
+          </a:xfrm>
+          <a:prstGeom prst="rect">
+            <a:avLst/>
+          </a:prstGeom>
+          <a:noFill/>
+        </p:spPr>
+        <p:txBody>
+          <a:bodyPr wrap="square" anchor="ctr">
+            <a:spAutoFit/>
+          </a:bodyPr>
+          <a:lstStyle/>
+          <a:p>
+            <a:pPr algn="ctr">
+              <a:spcAft>
+                <a:spcPts val="0"/>
+              </a:spcAft>
+            </a:pPr>
+            <a:r>
+              <a:rPr sz="1150" b="1">
+                <a:solidFill>
+                  <a:srgbClr val="5B6777"/>
+                </a:solidFill>
+                <a:latin typeface="Apple SD Gothic Neo"/>
+              </a:rPr>
+              <a:t>표본 단위: 9 settings · 77 physical units</a:t>
+            </a:r>
+          </a:p>
+        </p:txBody>
+      </p:sp>
+      <p:sp>
+        <p:nvSpPr>
+          <p:cNvPr id="27" name="Rounded Rectangle 26"/>
+          <p:cNvSpPr/>
+          <p:nvPr/>
+        </p:nvSpPr>
+        <p:spPr>
+          <a:xfrm>
+            <a:off x="8046720" y="1261872"/>
+            <a:ext cx="3520440" cy="4526280"/>
           </a:xfrm>
           <a:prstGeom prst="roundRect">
             <a:avLst/>
@@ -5855,14 +6465,53 @@
       </p:sp>
       <p:sp>
         <p:nvSpPr>
-          <p:cNvPr id="13" name="TextBox 12"/>
-          <p:cNvSpPr txBox="1"/>
-          <p:nvPr/>
-        </p:nvSpPr>
-        <p:spPr>
-          <a:xfrm>
-            <a:off x="6446520" y="1664208"/>
-            <a:ext cx="2194560" cy="548640"/>
+          <p:cNvPr id="28" name="TextBox 27"/>
+          <p:cNvSpPr txBox="1"/>
+          <p:nvPr/>
+        </p:nvSpPr>
+        <p:spPr>
+          <a:xfrm>
+            <a:off x="8321040" y="1527048"/>
+            <a:ext cx="2971800" cy="384048"/>
+          </a:xfrm>
+          <a:prstGeom prst="rect">
+            <a:avLst/>
+          </a:prstGeom>
+          <a:noFill/>
+        </p:spPr>
+        <p:txBody>
+          <a:bodyPr wrap="square" anchor="ctr">
+            <a:spAutoFit/>
+          </a:bodyPr>
+          <a:lstStyle/>
+          <a:p>
+            <a:pPr algn="l">
+              <a:spcAft>
+                <a:spcPts val="0"/>
+              </a:spcAft>
+            </a:pPr>
+            <a:r>
+              <a:rPr sz="1800" b="1">
+                <a:solidFill>
+                  <a:srgbClr val="2D9168"/>
+                </a:solidFill>
+                <a:latin typeface="Apple SD Gothic Neo"/>
+              </a:rPr>
+              <a:t>무슨 결론인가</a:t>
+            </a:r>
+          </a:p>
+        </p:txBody>
+      </p:sp>
+      <p:sp>
+        <p:nvSpPr>
+          <p:cNvPr id="29" name="TextBox 28"/>
+          <p:cNvSpPr txBox="1"/>
+          <p:nvPr/>
+        </p:nvSpPr>
+        <p:spPr>
+          <a:xfrm>
+            <a:off x="8321040" y="2130552"/>
+            <a:ext cx="2971800" cy="502920"/>
           </a:xfrm>
           <a:prstGeom prst="rect">
             <a:avLst/>
@@ -5881,27 +6530,27 @@
               </a:spcAft>
             </a:pPr>
             <a:r>
-              <a:rPr sz="2200" b="1">
+              <a:rPr sz="2400" b="1">
                 <a:solidFill>
                   <a:srgbClr val="2D9168"/>
                 </a:solidFill>
                 <a:latin typeface="Apple SD Gothic Neo"/>
               </a:rPr>
-              <a:t>33.8%</a:t>
-            </a:r>
-          </a:p>
-        </p:txBody>
-      </p:sp>
-      <p:sp>
-        <p:nvSpPr>
-          <p:cNvPr id="14" name="TextBox 13"/>
-          <p:cNvSpPr txBox="1"/>
-          <p:nvPr/>
-        </p:nvSpPr>
-        <p:spPr>
-          <a:xfrm>
-            <a:off x="6446520" y="2359152"/>
-            <a:ext cx="2194560" cy="594360"/>
+              <a:t>9 / 9 우세</a:t>
+            </a:r>
+          </a:p>
+        </p:txBody>
+      </p:sp>
+      <p:sp>
+        <p:nvSpPr>
+          <p:cNvPr id="30" name="TextBox 29"/>
+          <p:cNvSpPr txBox="1"/>
+          <p:nvPr/>
+        </p:nvSpPr>
+        <p:spPr>
+          <a:xfrm>
+            <a:off x="8321040" y="2697480"/>
+            <a:ext cx="2971800" cy="320040"/>
           </a:xfrm>
           <a:prstGeom prst="rect">
             <a:avLst/>
@@ -5920,28 +6569,180 @@
               </a:spcAft>
             </a:pPr>
             <a:r>
-              <a:rPr sz="1150" b="1">
+              <a:rPr sz="1250" b="1">
                 <a:solidFill>
                   <a:srgbClr val="1A232F"/>
                 </a:solidFill>
                 <a:latin typeface="Apple SD Gothic Neo"/>
               </a:rPr>
-              <a:t>geometric-mean
-RMSE 감소</a:t>
-            </a:r>
-          </a:p>
-        </p:txBody>
-      </p:sp>
-      <p:sp>
-        <p:nvSpPr>
-          <p:cNvPr id="15" name="Rounded Rectangle 14"/>
+              <a:t>exact sign p = .0039</a:t>
+            </a:r>
+          </a:p>
+        </p:txBody>
+      </p:sp>
+      <p:cxnSp>
+        <p:nvCxnSpPr>
+          <p:cNvPr id="31" name="Connector 30"/>
+          <p:cNvCxnSpPr/>
+          <p:nvPr/>
+        </p:nvCxnSpPr>
+        <p:spPr>
+          <a:xfrm>
+            <a:off x="8366760" y="3246120"/>
+            <a:ext cx="2880360" cy="0"/>
+          </a:xfrm>
+          <a:prstGeom prst="line">
+            <a:avLst/>
+          </a:prstGeom>
+          <a:ln w="19050">
+            <a:solidFill>
+              <a:srgbClr val="2D9168"/>
+            </a:solidFill>
+          </a:ln>
+        </p:spPr>
+        <p:style>
+          <a:lnRef idx="2">
+            <a:schemeClr val="accent1"/>
+          </a:lnRef>
+          <a:fillRef idx="0">
+            <a:schemeClr val="accent1"/>
+          </a:fillRef>
+          <a:effectRef idx="1">
+            <a:schemeClr val="accent1"/>
+          </a:effectRef>
+          <a:fontRef idx="minor">
+            <a:schemeClr val="tx1"/>
+          </a:fontRef>
+        </p:style>
+      </p:cxnSp>
+      <p:sp>
+        <p:nvSpPr>
+          <p:cNvPr id="32" name="TextBox 31"/>
+          <p:cNvSpPr txBox="1"/>
+          <p:nvPr/>
+        </p:nvSpPr>
+        <p:spPr>
+          <a:xfrm>
+            <a:off x="8321040" y="3502152"/>
+            <a:ext cx="2971800" cy="502920"/>
+          </a:xfrm>
+          <a:prstGeom prst="rect">
+            <a:avLst/>
+          </a:prstGeom>
+          <a:noFill/>
+        </p:spPr>
+        <p:txBody>
+          <a:bodyPr wrap="square" anchor="ctr">
+            <a:spAutoFit/>
+          </a:bodyPr>
+          <a:lstStyle/>
+          <a:p>
+            <a:pPr algn="ctr">
+              <a:spcAft>
+                <a:spcPts val="0"/>
+              </a:spcAft>
+            </a:pPr>
+            <a:r>
+              <a:rPr sz="1700" b="1">
+                <a:solidFill>
+                  <a:srgbClr val="2D9168"/>
+                </a:solidFill>
+                <a:latin typeface="Apple SD Gothic Neo"/>
+              </a:rPr>
+              <a:t>평균 RMSE 33.8% 감소</a:t>
+            </a:r>
+          </a:p>
+        </p:txBody>
+      </p:sp>
+      <p:sp>
+        <p:nvSpPr>
+          <p:cNvPr id="33" name="TextBox 32"/>
+          <p:cNvSpPr txBox="1"/>
+          <p:nvPr/>
+        </p:nvSpPr>
+        <p:spPr>
+          <a:xfrm>
+            <a:off x="8321040" y="4096512"/>
+            <a:ext cx="2971800" cy="502920"/>
+          </a:xfrm>
+          <a:prstGeom prst="rect">
+            <a:avLst/>
+          </a:prstGeom>
+          <a:noFill/>
+        </p:spPr>
+        <p:txBody>
+          <a:bodyPr wrap="square" anchor="ctr">
+            <a:spAutoFit/>
+          </a:bodyPr>
+          <a:lstStyle/>
+          <a:p>
+            <a:pPr algn="ctr">
+              <a:spcAft>
+                <a:spcPts val="0"/>
+              </a:spcAft>
+            </a:pPr>
+            <a:r>
+              <a:rPr sz="1400" b="1">
+                <a:solidFill>
+                  <a:srgbClr val="1A232F"/>
+                </a:solidFill>
+                <a:latin typeface="Apple SD Gothic Neo"/>
+              </a:rPr>
+              <a:t>95% CI: 15.8%–48.6%</a:t>
+            </a:r>
+          </a:p>
+        </p:txBody>
+      </p:sp>
+      <p:sp>
+        <p:nvSpPr>
+          <p:cNvPr id="34" name="TextBox 33"/>
+          <p:cNvSpPr txBox="1"/>
+          <p:nvPr/>
+        </p:nvSpPr>
+        <p:spPr>
+          <a:xfrm>
+            <a:off x="8321040" y="4846320"/>
+            <a:ext cx="2971800" cy="594360"/>
+          </a:xfrm>
+          <a:prstGeom prst="rect">
+            <a:avLst/>
+          </a:prstGeom>
+          <a:noFill/>
+        </p:spPr>
+        <p:txBody>
+          <a:bodyPr wrap="square" anchor="ctr">
+            <a:spAutoFit/>
+          </a:bodyPr>
+          <a:lstStyle/>
+          <a:p>
+            <a:pPr algn="ctr">
+              <a:spcAft>
+                <a:spcPts val="0"/>
+              </a:spcAft>
+            </a:pPr>
+            <a:r>
+              <a:rPr sz="1200" b="1">
+                <a:solidFill>
+                  <a:srgbClr val="5B6777"/>
+                </a:solidFill>
+                <a:latin typeface="Apple SD Gothic Neo"/>
+              </a:rPr>
+              <a:t>해석: prior–residual 구조의
+평균 오차 감소가 0보다 큼</a:t>
+            </a:r>
+          </a:p>
+        </p:txBody>
+      </p:sp>
+      <p:sp>
+        <p:nvSpPr>
+          <p:cNvPr id="35" name="Rounded Rectangle 34"/>
           <p:cNvSpPr/>
           <p:nvPr/>
         </p:nvSpPr>
         <p:spPr>
           <a:xfrm>
-            <a:off x="9326880" y="1417320"/>
-            <a:ext cx="2194560" cy="1828800"/>
+            <a:off x="868680" y="5989320"/>
+            <a:ext cx="10424160" cy="438912"/>
           </a:xfrm>
           <a:prstGeom prst="roundRect">
             <a:avLst/>
@@ -5979,14 +6780,14 @@
       </p:sp>
       <p:sp>
         <p:nvSpPr>
-          <p:cNvPr id="16" name="TextBox 15"/>
-          <p:cNvSpPr txBox="1"/>
-          <p:nvPr/>
-        </p:nvSpPr>
-        <p:spPr>
-          <a:xfrm>
-            <a:off x="9326880" y="1664208"/>
-            <a:ext cx="2194560" cy="548640"/>
+          <p:cNvPr id="36" name="TextBox 35"/>
+          <p:cNvSpPr txBox="1"/>
+          <p:nvPr/>
+        </p:nvSpPr>
+        <p:spPr>
+          <a:xfrm>
+            <a:off x="1051560" y="6016752"/>
+            <a:ext cx="10058400" cy="365760"/>
           </a:xfrm>
           <a:prstGeom prst="rect">
             <a:avLst/>
@@ -6005,458 +6806,13 @@
               </a:spcAft>
             </a:pPr>
             <a:r>
-              <a:rPr sz="2200" b="1">
-                <a:solidFill>
-                  <a:srgbClr val="E67E34"/>
-                </a:solidFill>
-                <a:latin typeface="Apple SD Gothic Neo"/>
-              </a:rPr>
-              <a:t>[0.17, 0.67]</a:t>
-            </a:r>
-          </a:p>
-        </p:txBody>
-      </p:sp>
-      <p:sp>
-        <p:nvSpPr>
-          <p:cNvPr id="17" name="TextBox 16"/>
-          <p:cNvSpPr txBox="1"/>
-          <p:nvPr/>
-        </p:nvSpPr>
-        <p:spPr>
-          <a:xfrm>
-            <a:off x="9326880" y="2359152"/>
-            <a:ext cx="2194560" cy="594360"/>
-          </a:xfrm>
-          <a:prstGeom prst="rect">
-            <a:avLst/>
-          </a:prstGeom>
-          <a:noFill/>
-        </p:spPr>
-        <p:txBody>
-          <a:bodyPr wrap="square" anchor="ctr">
-            <a:spAutoFit/>
-          </a:bodyPr>
-          <a:lstStyle/>
-          <a:p>
-            <a:pPr algn="ctr">
-              <a:spcAft>
-                <a:spcPts val="0"/>
-              </a:spcAft>
-            </a:pPr>
-            <a:r>
               <a:rPr sz="1150" b="1">
                 <a:solidFill>
                   <a:srgbClr val="1A232F"/>
                 </a:solidFill>
                 <a:latin typeface="Apple SD Gothic Neo"/>
               </a:rPr>
-              <a:t>hierarchical CI
-log-RMSE gain</a:t>
-            </a:r>
-          </a:p>
-        </p:txBody>
-      </p:sp>
-      <p:cxnSp>
-        <p:nvCxnSpPr>
-          <p:cNvPr id="18" name="Connector 17"/>
-          <p:cNvCxnSpPr/>
-          <p:nvPr/>
-        </p:nvCxnSpPr>
-        <p:spPr>
-          <a:xfrm>
-            <a:off x="914400" y="3749039"/>
-            <a:ext cx="10332720" cy="0"/>
-          </a:xfrm>
-          <a:prstGeom prst="line">
-            <a:avLst/>
-          </a:prstGeom>
-          <a:ln w="15240">
-            <a:solidFill>
-              <a:srgbClr val="DCE1E6"/>
-            </a:solidFill>
-          </a:ln>
-        </p:spPr>
-        <p:style>
-          <a:lnRef idx="2">
-            <a:schemeClr val="accent1"/>
-          </a:lnRef>
-          <a:fillRef idx="0">
-            <a:schemeClr val="accent1"/>
-          </a:fillRef>
-          <a:effectRef idx="1">
-            <a:schemeClr val="accent1"/>
-          </a:effectRef>
-          <a:fontRef idx="minor">
-            <a:schemeClr val="tx1"/>
-          </a:fontRef>
-        </p:style>
-      </p:cxnSp>
-      <p:sp>
-        <p:nvSpPr>
-          <p:cNvPr id="19" name="TextBox 18"/>
-          <p:cNvSpPr txBox="1"/>
-          <p:nvPr/>
-        </p:nvSpPr>
-        <p:spPr>
-          <a:xfrm>
-            <a:off x="822960" y="4069080"/>
-            <a:ext cx="2286000" cy="365760"/>
-          </a:xfrm>
-          <a:prstGeom prst="rect">
-            <a:avLst/>
-          </a:prstGeom>
-          <a:noFill/>
-        </p:spPr>
-        <p:txBody>
-          <a:bodyPr wrap="square" anchor="ctr">
-            <a:spAutoFit/>
-          </a:bodyPr>
-          <a:lstStyle/>
-          <a:p>
-            <a:pPr algn="l">
-              <a:spcAft>
-                <a:spcPts val="0"/>
-              </a:spcAft>
-            </a:pPr>
-            <a:r>
-              <a:rPr sz="1500" b="1">
-                <a:solidFill>
-                  <a:srgbClr val="1A232F"/>
-                </a:solidFill>
-                <a:latin typeface="Apple SD Gothic Neo"/>
-              </a:rPr>
-              <a:t>개별 BH 근거</a:t>
-            </a:r>
-          </a:p>
-        </p:txBody>
-      </p:sp>
-      <p:sp>
-        <p:nvSpPr>
-          <p:cNvPr id="20" name="Rounded Rectangle 19"/>
-          <p:cNvSpPr/>
-          <p:nvPr/>
-        </p:nvSpPr>
-        <p:spPr>
-          <a:xfrm>
-            <a:off x="2743200" y="4087368"/>
-            <a:ext cx="1417320" cy="329184"/>
-          </a:xfrm>
-          <a:prstGeom prst="roundRect">
-            <a:avLst/>
-          </a:prstGeom>
-          <a:solidFill>
-            <a:srgbClr val="1F6BB5"/>
-          </a:solidFill>
-          <a:ln w="15240">
-            <a:solidFill>
-              <a:srgbClr val="1F6BB5"/>
-            </a:solidFill>
-          </a:ln>
-        </p:spPr>
-        <p:style>
-          <a:lnRef idx="1">
-            <a:schemeClr val="accent1"/>
-          </a:lnRef>
-          <a:fillRef idx="3">
-            <a:schemeClr val="accent1"/>
-          </a:fillRef>
-          <a:effectRef idx="2">
-            <a:schemeClr val="accent1"/>
-          </a:effectRef>
-          <a:fontRef idx="minor">
-            <a:schemeClr val="lt1"/>
-          </a:fontRef>
-        </p:style>
-        <p:txBody>
-          <a:bodyPr rtlCol="0" anchor="ctr"/>
-          <a:lstStyle/>
-          <a:p>
-            <a:pPr algn="ctr"/>
-          </a:p>
-        </p:txBody>
-      </p:sp>
-      <p:sp>
-        <p:nvSpPr>
-          <p:cNvPr id="21" name="TextBox 20"/>
-          <p:cNvSpPr txBox="1"/>
-          <p:nvPr/>
-        </p:nvSpPr>
-        <p:spPr>
-          <a:xfrm>
-            <a:off x="2743200" y="4087368"/>
-            <a:ext cx="1417320" cy="329184"/>
-          </a:xfrm>
-          <a:prstGeom prst="rect">
-            <a:avLst/>
-          </a:prstGeom>
-          <a:noFill/>
-        </p:spPr>
-        <p:txBody>
-          <a:bodyPr wrap="square" anchor="ctr">
-            <a:spAutoFit/>
-          </a:bodyPr>
-          <a:lstStyle/>
-          <a:p>
-            <a:pPr algn="ctr">
-              <a:spcAft>
-                <a:spcPts val="0"/>
-              </a:spcAft>
-            </a:pPr>
-            <a:r>
-              <a:rPr sz="1100" b="1">
-                <a:solidFill>
-                  <a:srgbClr val="FFFFFF"/>
-                </a:solidFill>
-                <a:latin typeface="Apple SD Gothic Neo"/>
-              </a:rPr>
-              <a:t>Sunwoda</a:t>
-            </a:r>
-          </a:p>
-        </p:txBody>
-      </p:sp>
-      <p:sp>
-        <p:nvSpPr>
-          <p:cNvPr id="22" name="Rounded Rectangle 21"/>
-          <p:cNvSpPr/>
-          <p:nvPr/>
-        </p:nvSpPr>
-        <p:spPr>
-          <a:xfrm>
-            <a:off x="4343400" y="4087368"/>
-            <a:ext cx="1417320" cy="329184"/>
-          </a:xfrm>
-          <a:prstGeom prst="roundRect">
-            <a:avLst/>
-          </a:prstGeom>
-          <a:solidFill>
-            <a:srgbClr val="2D9168"/>
-          </a:solidFill>
-          <a:ln w="15240">
-            <a:solidFill>
-              <a:srgbClr val="2D9168"/>
-            </a:solidFill>
-          </a:ln>
-        </p:spPr>
-        <p:style>
-          <a:lnRef idx="1">
-            <a:schemeClr val="accent1"/>
-          </a:lnRef>
-          <a:fillRef idx="3">
-            <a:schemeClr val="accent1"/>
-          </a:fillRef>
-          <a:effectRef idx="2">
-            <a:schemeClr val="accent1"/>
-          </a:effectRef>
-          <a:fontRef idx="minor">
-            <a:schemeClr val="lt1"/>
-          </a:fontRef>
-        </p:style>
-        <p:txBody>
-          <a:bodyPr rtlCol="0" anchor="ctr"/>
-          <a:lstStyle/>
-          <a:p>
-            <a:pPr algn="ctr"/>
-          </a:p>
-        </p:txBody>
-      </p:sp>
-      <p:sp>
-        <p:nvSpPr>
-          <p:cNvPr id="23" name="TextBox 22"/>
-          <p:cNvSpPr txBox="1"/>
-          <p:nvPr/>
-        </p:nvSpPr>
-        <p:spPr>
-          <a:xfrm>
-            <a:off x="4343400" y="4087368"/>
-            <a:ext cx="1417320" cy="329184"/>
-          </a:xfrm>
-          <a:prstGeom prst="rect">
-            <a:avLst/>
-          </a:prstGeom>
-          <a:noFill/>
-        </p:spPr>
-        <p:txBody>
-          <a:bodyPr wrap="square" anchor="ctr">
-            <a:spAutoFit/>
-          </a:bodyPr>
-          <a:lstStyle/>
-          <a:p>
-            <a:pPr algn="ctr">
-              <a:spcAft>
-                <a:spcPts val="0"/>
-              </a:spcAft>
-            </a:pPr>
-            <a:r>
-              <a:rPr sz="1100" b="1">
-                <a:solidFill>
-                  <a:srgbClr val="FFFFFF"/>
-                </a:solidFill>
-                <a:latin typeface="Apple SD Gothic Neo"/>
-              </a:rPr>
-              <a:t>MATR-b2</a:t>
-            </a:r>
-          </a:p>
-        </p:txBody>
-      </p:sp>
-      <p:sp>
-        <p:nvSpPr>
-          <p:cNvPr id="24" name="TextBox 23"/>
-          <p:cNvSpPr txBox="1"/>
-          <p:nvPr/>
-        </p:nvSpPr>
-        <p:spPr>
-          <a:xfrm>
-            <a:off x="822960" y="4800600"/>
-            <a:ext cx="2286000" cy="365760"/>
-          </a:xfrm>
-          <a:prstGeom prst="rect">
-            <a:avLst/>
-          </a:prstGeom>
-          <a:noFill/>
-        </p:spPr>
-        <p:txBody>
-          <a:bodyPr wrap="square" anchor="ctr">
-            <a:spAutoFit/>
-          </a:bodyPr>
-          <a:lstStyle/>
-          <a:p>
-            <a:pPr algn="l">
-              <a:spcAft>
-                <a:spcPts val="0"/>
-              </a:spcAft>
-            </a:pPr>
-            <a:r>
-              <a:rPr sz="1500" b="1">
-                <a:solidFill>
-                  <a:srgbClr val="1A232F"/>
-                </a:solidFill>
-                <a:latin typeface="Apple SD Gothic Neo"/>
-              </a:rPr>
-              <a:t>해석 제한</a:t>
-            </a:r>
-          </a:p>
-        </p:txBody>
-      </p:sp>
-      <p:sp>
-        <p:nvSpPr>
-          <p:cNvPr id="25" name="TextBox 24"/>
-          <p:cNvSpPr txBox="1"/>
-          <p:nvPr/>
-        </p:nvSpPr>
-        <p:spPr>
-          <a:xfrm>
-            <a:off x="2743200" y="4690872"/>
-            <a:ext cx="8046720" cy="731520"/>
-          </a:xfrm>
-          <a:prstGeom prst="rect">
-            <a:avLst/>
-          </a:prstGeom>
-          <a:noFill/>
-        </p:spPr>
-        <p:txBody>
-          <a:bodyPr wrap="square" anchor="ctr">
-            <a:spAutoFit/>
-          </a:bodyPr>
-          <a:lstStyle/>
-          <a:p>
-            <a:pPr algn="l">
-              <a:spcAft>
-                <a:spcPts val="0"/>
-              </a:spcAft>
-            </a:pPr>
-            <a:r>
-              <a:rPr sz="1250" b="1">
-                <a:solidFill>
-                  <a:srgbClr val="5B6777"/>
-                </a:solidFill>
-                <a:latin typeface="Apple SD Gothic Neo"/>
-              </a:rPr>
-              <a:t>5 seeds는 독립 cohort가 아님 · NASA/N-CMAPSS unit 수가 작음
-retrospective split은 prospective 확증을 대체하지 않음</a:t>
-            </a:r>
-          </a:p>
-        </p:txBody>
-      </p:sp>
-      <p:sp>
-        <p:nvSpPr>
-          <p:cNvPr id="26" name="Rounded Rectangle 25"/>
-          <p:cNvSpPr/>
-          <p:nvPr/>
-        </p:nvSpPr>
-        <p:spPr>
-          <a:xfrm>
-            <a:off x="822960" y="5715000"/>
-            <a:ext cx="10698480" cy="502920"/>
-          </a:xfrm>
-          <a:prstGeom prst="roundRect">
-            <a:avLst/>
-          </a:prstGeom>
-          <a:solidFill>
-            <a:srgbClr val="FBEBEB"/>
-          </a:solidFill>
-          <a:ln w="15240">
-            <a:solidFill>
-              <a:srgbClr val="BE4141"/>
-            </a:solidFill>
-          </a:ln>
-        </p:spPr>
-        <p:style>
-          <a:lnRef idx="1">
-            <a:schemeClr val="accent1"/>
-          </a:lnRef>
-          <a:fillRef idx="3">
-            <a:schemeClr val="accent1"/>
-          </a:fillRef>
-          <a:effectRef idx="2">
-            <a:schemeClr val="accent1"/>
-          </a:effectRef>
-          <a:fontRef idx="minor">
-            <a:schemeClr val="lt1"/>
-          </a:fontRef>
-        </p:style>
-        <p:txBody>
-          <a:bodyPr rtlCol="0" anchor="ctr"/>
-          <a:lstStyle/>
-          <a:p>
-            <a:pPr algn="ctr"/>
-          </a:p>
-        </p:txBody>
-      </p:sp>
-      <p:sp>
-        <p:nvSpPr>
-          <p:cNvPr id="27" name="TextBox 26"/>
-          <p:cNvSpPr txBox="1"/>
-          <p:nvPr/>
-        </p:nvSpPr>
-        <p:spPr>
-          <a:xfrm>
-            <a:off x="1051560" y="5769864"/>
-            <a:ext cx="10241280" cy="384048"/>
-          </a:xfrm>
-          <a:prstGeom prst="rect">
-            <a:avLst/>
-          </a:prstGeom>
-          <a:noFill/>
-        </p:spPr>
-        <p:txBody>
-          <a:bodyPr wrap="square" anchor="ctr">
-            <a:spAutoFit/>
-          </a:bodyPr>
-          <a:lstStyle/>
-          <a:p>
-            <a:pPr algn="ctr">
-              <a:spcAft>
-                <a:spcPts val="0"/>
-              </a:spcAft>
-            </a:pPr>
-            <a:r>
-              <a:rPr sz="1200" b="1">
-                <a:solidFill>
-                  <a:srgbClr val="BE4141"/>
-                </a:solidFill>
-                <a:latin typeface="Apple SD Gothic Neo"/>
-              </a:rPr>
-              <a:t>FEMTO v1_declared abstention은 Final BH family에서 제외</a:t>
+              <a:t>log-RMSE CI [0.17, 0.67]은 발표에서 위의 ‘RMSE 15.8%–48.6% 감소’로 풀어 쓴다.</a:t>
             </a:r>
           </a:p>
         </p:txBody>
@@ -6521,7 +6877,7 @@
                 </a:solidFill>
                 <a:latin typeface="Apple SD Gothic Neo"/>
               </a:rPr>
-              <a:t>무엇을 주장하고, 무엇을 주장하지 않는가</a:t>
+              <a:t>검정 2·3 — 경쟁력과 구성요소 효과는 따로 검정</a:t>
             </a:r>
           </a:p>
         </p:txBody>
@@ -6560,7 +6916,7 @@
                 </a:solidFill>
                 <a:latin typeface="Apple SD Gothic Neo"/>
               </a:rPr>
-              <a:t>성과보다 실행 계약의 범위를 먼저 고정한다.</a:t>
+              <a:t>내부 구조 검정, 외부 baseline 비교, component ablation을 섞지 않는다.</a:t>
             </a:r>
           </a:p>
         </p:txBody>
@@ -6647,18 +7003,18 @@
         </p:nvSpPr>
         <p:spPr>
           <a:xfrm>
-            <a:off x="658368" y="1325880"/>
-            <a:ext cx="5257800" cy="4434840"/>
+            <a:off x="594360" y="1298448"/>
+            <a:ext cx="3429000" cy="4892040"/>
           </a:xfrm>
           <a:prstGeom prst="roundRect">
             <a:avLst/>
           </a:prstGeom>
           <a:solidFill>
-            <a:srgbClr val="E7F6EF"/>
+            <a:srgbClr val="FDF1E6"/>
           </a:solidFill>
           <a:ln w="15240">
             <a:solidFill>
-              <a:srgbClr val="2D9168"/>
+              <a:srgbClr val="E67E34"/>
             </a:solidFill>
           </a:ln>
         </p:spPr>
@@ -6692,16 +7048,55 @@
         </p:nvSpPr>
         <p:spPr>
           <a:xfrm>
-            <a:off x="960120" y="1600200"/>
-            <a:ext cx="4663440" cy="411480"/>
-          </a:xfrm>
-          <a:prstGeom prst="rect">
-            <a:avLst/>
-          </a:prstGeom>
-          <a:noFill/>
-        </p:spPr>
-        <p:txBody>
-          <a:bodyPr wrap="square" anchor="ctr">
+            <a:off x="822960" y="1517904"/>
+            <a:ext cx="2971800" cy="384048"/>
+          </a:xfrm>
+          <a:prstGeom prst="rect">
+            <a:avLst/>
+          </a:prstGeom>
+          <a:noFill/>
+        </p:spPr>
+        <p:txBody>
+          <a:bodyPr wrap="square" anchor="ctr">
+            <a:spAutoFit/>
+          </a:bodyPr>
+          <a:lstStyle/>
+          <a:p>
+            <a:pPr algn="ctr">
+              <a:spcAft>
+                <a:spcPts val="0"/>
+              </a:spcAft>
+            </a:pPr>
+            <a:r>
+              <a:rPr sz="1650" b="1">
+                <a:solidFill>
+                  <a:srgbClr val="E67E34"/>
+                </a:solidFill>
+                <a:latin typeface="Apple SD Gothic Neo"/>
+              </a:rPr>
+              <a:t>검정 2 · 외부 경쟁력</a:t>
+            </a:r>
+          </a:p>
+        </p:txBody>
+      </p:sp>
+      <p:sp>
+        <p:nvSpPr>
+          <p:cNvPr id="8" name="TextBox 7"/>
+          <p:cNvSpPr txBox="1"/>
+          <p:nvPr/>
+        </p:nvSpPr>
+        <p:spPr>
+          <a:xfrm>
+            <a:off x="868680" y="1993392"/>
+            <a:ext cx="2880360" cy="3886200"/>
+          </a:xfrm>
+          <a:prstGeom prst="rect">
+            <a:avLst/>
+          </a:prstGeom>
+          <a:noFill/>
+        </p:spPr>
+        <p:txBody>
+          <a:bodyPr wrap="square" anchor="t">
             <a:spAutoFit/>
           </a:bodyPr>
           <a:lstStyle/>
@@ -6712,55 +7107,22 @@
               </a:spcAft>
             </a:pPr>
             <a:r>
-              <a:rPr sz="2100" b="1">
-                <a:solidFill>
-                  <a:srgbClr val="2D9168"/>
-                </a:solidFill>
-                <a:latin typeface="Apple SD Gothic Neo"/>
-              </a:rPr>
-              <a:t>말할 수 있음</a:t>
-            </a:r>
-          </a:p>
-        </p:txBody>
-      </p:sp>
-      <p:sp>
-        <p:nvSpPr>
-          <p:cNvPr id="8" name="TextBox 7"/>
-          <p:cNvSpPr txBox="1"/>
-          <p:nvPr/>
-        </p:nvSpPr>
-        <p:spPr>
-          <a:xfrm>
-            <a:off x="960120" y="2304288"/>
-            <a:ext cx="4617720" cy="2560320"/>
-          </a:xfrm>
-          <a:prstGeom prst="rect">
-            <a:avLst/>
-          </a:prstGeom>
-          <a:noFill/>
-        </p:spPr>
-        <p:txBody>
-          <a:bodyPr wrap="square" anchor="ctr">
-            <a:spAutoFit/>
-          </a:bodyPr>
-          <a:lstStyle/>
-          <a:p>
-            <a:pPr algn="l">
-              <a:spcAft>
-                <a:spcPts val="0"/>
-              </a:spcAft>
-            </a:pPr>
-            <a:r>
-              <a:rPr sz="1600" b="1">
+              <a:rPr sz="1170" b="0">
                 <a:solidFill>
                   <a:srgbClr val="1A232F"/>
                 </a:solidFill>
                 <a:latin typeface="Apple SD Gothic Neo"/>
               </a:rPr>
-              <a:t>✓ 9-setting summary gain
-✓ prior–residual 역할 분리
-✓ executor 효과의 반례
-✓ test 전 route 동결</a:t>
+              <a:t>질문
+강한 ML baseline보다 좋은가?
+비교
+각 setting의 동일예산
+30-candidate 최강 baseline
+결과
+8/9 우세 · p=.0391
+Virkler: FT가 +.002 우세
+주장
+동일예산 범위에서 경쟁력 확보</a:t>
             </a:r>
           </a:p>
         </p:txBody>
@@ -6773,8 +7135,143 @@
         </p:nvSpPr>
         <p:spPr>
           <a:xfrm>
-            <a:off x="6272784" y="1325880"/>
-            <a:ext cx="5257800" cy="4434840"/>
+            <a:off x="4315968" y="1298448"/>
+            <a:ext cx="3429000" cy="4892040"/>
+          </a:xfrm>
+          <a:prstGeom prst="roundRect">
+            <a:avLst/>
+          </a:prstGeom>
+          <a:solidFill>
+            <a:srgbClr val="E9F3FB"/>
+          </a:solidFill>
+          <a:ln w="15240">
+            <a:solidFill>
+              <a:srgbClr val="1F6BB5"/>
+            </a:solidFill>
+          </a:ln>
+        </p:spPr>
+        <p:style>
+          <a:lnRef idx="1">
+            <a:schemeClr val="accent1"/>
+          </a:lnRef>
+          <a:fillRef idx="3">
+            <a:schemeClr val="accent1"/>
+          </a:fillRef>
+          <a:effectRef idx="2">
+            <a:schemeClr val="accent1"/>
+          </a:effectRef>
+          <a:fontRef idx="minor">
+            <a:schemeClr val="lt1"/>
+          </a:fontRef>
+        </p:style>
+        <p:txBody>
+          <a:bodyPr rtlCol="0" anchor="ctr"/>
+          <a:lstStyle/>
+          <a:p>
+            <a:pPr algn="ctr"/>
+          </a:p>
+        </p:txBody>
+      </p:sp>
+      <p:sp>
+        <p:nvSpPr>
+          <p:cNvPr id="10" name="TextBox 9"/>
+          <p:cNvSpPr txBox="1"/>
+          <p:nvPr/>
+        </p:nvSpPr>
+        <p:spPr>
+          <a:xfrm>
+            <a:off x="4544568" y="1517904"/>
+            <a:ext cx="2971800" cy="384048"/>
+          </a:xfrm>
+          <a:prstGeom prst="rect">
+            <a:avLst/>
+          </a:prstGeom>
+          <a:noFill/>
+        </p:spPr>
+        <p:txBody>
+          <a:bodyPr wrap="square" anchor="ctr">
+            <a:spAutoFit/>
+          </a:bodyPr>
+          <a:lstStyle/>
+          <a:p>
+            <a:pPr algn="ctr">
+              <a:spcAft>
+                <a:spcPts val="0"/>
+              </a:spcAft>
+            </a:pPr>
+            <a:r>
+              <a:rPr sz="1650" b="1">
+                <a:solidFill>
+                  <a:srgbClr val="1F6BB5"/>
+                </a:solidFill>
+                <a:latin typeface="Apple SD Gothic Neo"/>
+              </a:rPr>
+              <a:t>검정 3 · component</a:t>
+            </a:r>
+          </a:p>
+        </p:txBody>
+      </p:sp>
+      <p:sp>
+        <p:nvSpPr>
+          <p:cNvPr id="11" name="TextBox 10"/>
+          <p:cNvSpPr txBox="1"/>
+          <p:nvPr/>
+        </p:nvSpPr>
+        <p:spPr>
+          <a:xfrm>
+            <a:off x="4590288" y="1993392"/>
+            <a:ext cx="2880360" cy="3886200"/>
+          </a:xfrm>
+          <a:prstGeom prst="rect">
+            <a:avLst/>
+          </a:prstGeom>
+          <a:noFill/>
+        </p:spPr>
+        <p:txBody>
+          <a:bodyPr wrap="square" anchor="t">
+            <a:spAutoFit/>
+          </a:bodyPr>
+          <a:lstStyle/>
+          <a:p>
+            <a:pPr algn="l">
+              <a:spcAft>
+                <a:spcPts val="0"/>
+              </a:spcAft>
+            </a:pPr>
+            <a:r>
+              <a:rPr sz="1170" b="0">
+                <a:solidFill>
+                  <a:srgbClr val="1A232F"/>
+                </a:solidFill>
+                <a:latin typeface="Apple SD Gothic Neo"/>
+              </a:rPr>
+              <a:t>질문
+각 optional module을 왜 켜거나 끄나?
+방법
+같은 prior family 안에서 on vs off
+physical-unit 효과 · 24개 BH 보정
+도움
+MICH dual: .468→.751 (q=.031)
+HUST·MATR-b2 transport 유의
+해로움
+RWTH dual: .878→.842 (q=.021)
+MICH fixed bound도 유의하게 악화
+결론
+모든 module을 항상 켜면 안 됨</a:t>
+            </a:r>
+          </a:p>
+        </p:txBody>
+      </p:sp>
+      <p:sp>
+        <p:nvSpPr>
+          <p:cNvPr id="12" name="Rounded Rectangle 11"/>
+          <p:cNvSpPr/>
+          <p:nvPr/>
+        </p:nvSpPr>
+        <p:spPr>
+          <a:xfrm>
+            <a:off x="8037575" y="1298448"/>
+            <a:ext cx="3429000" cy="4892040"/>
           </a:xfrm>
           <a:prstGeom prst="roundRect">
             <a:avLst/>
@@ -6812,22 +7309,61 @@
       </p:sp>
       <p:sp>
         <p:nvSpPr>
-          <p:cNvPr id="10" name="TextBox 9"/>
-          <p:cNvSpPr txBox="1"/>
-          <p:nvPr/>
-        </p:nvSpPr>
-        <p:spPr>
-          <a:xfrm>
-            <a:off x="6574536" y="1600200"/>
-            <a:ext cx="4663440" cy="411480"/>
-          </a:xfrm>
-          <a:prstGeom prst="rect">
-            <a:avLst/>
-          </a:prstGeom>
-          <a:noFill/>
-        </p:spPr>
-        <p:txBody>
-          <a:bodyPr wrap="square" anchor="ctr">
+          <p:cNvPr id="13" name="TextBox 12"/>
+          <p:cNvSpPr txBox="1"/>
+          <p:nvPr/>
+        </p:nvSpPr>
+        <p:spPr>
+          <a:xfrm>
+            <a:off x="8266175" y="1517904"/>
+            <a:ext cx="2971800" cy="384048"/>
+          </a:xfrm>
+          <a:prstGeom prst="rect">
+            <a:avLst/>
+          </a:prstGeom>
+          <a:noFill/>
+        </p:spPr>
+        <p:txBody>
+          <a:bodyPr wrap="square" anchor="ctr">
+            <a:spAutoFit/>
+          </a:bodyPr>
+          <a:lstStyle/>
+          <a:p>
+            <a:pPr algn="ctr">
+              <a:spcAft>
+                <a:spcPts val="0"/>
+              </a:spcAft>
+            </a:pPr>
+            <a:r>
+              <a:rPr sz="1650" b="1">
+                <a:solidFill>
+                  <a:srgbClr val="BE4141"/>
+                </a:solidFill>
+                <a:latin typeface="Apple SD Gothic Neo"/>
+              </a:rPr>
+              <a:t>아직 확증 안 된 것</a:t>
+            </a:r>
+          </a:p>
+        </p:txBody>
+      </p:sp>
+      <p:sp>
+        <p:nvSpPr>
+          <p:cNvPr id="14" name="TextBox 13"/>
+          <p:cNvSpPr txBox="1"/>
+          <p:nvPr/>
+        </p:nvSpPr>
+        <p:spPr>
+          <a:xfrm>
+            <a:off x="8311896" y="1993392"/>
+            <a:ext cx="2880360" cy="3886200"/>
+          </a:xfrm>
+          <a:prstGeom prst="rect">
+            <a:avLst/>
+          </a:prstGeom>
+          <a:noFill/>
+        </p:spPr>
+        <p:txBody>
+          <a:bodyPr wrap="square" anchor="t">
             <a:spAutoFit/>
           </a:bodyPr>
           <a:lstStyle/>
@@ -6838,55 +7374,20 @@
               </a:spcAft>
             </a:pPr>
             <a:r>
-              <a:rPr sz="2100" b="1">
-                <a:solidFill>
-                  <a:srgbClr val="BE4141"/>
-                </a:solidFill>
-                <a:latin typeface="Apple SD Gothic Neo"/>
-              </a:rPr>
-              <a:t>말하면 안 됨</a:t>
-            </a:r>
-          </a:p>
-        </p:txBody>
-      </p:sp>
-      <p:sp>
-        <p:nvSpPr>
-          <p:cNvPr id="11" name="TextBox 10"/>
-          <p:cNvSpPr txBox="1"/>
-          <p:nvPr/>
-        </p:nvSpPr>
-        <p:spPr>
-          <a:xfrm>
-            <a:off x="6574536" y="2304288"/>
-            <a:ext cx="4617720" cy="2560320"/>
-          </a:xfrm>
-          <a:prstGeom prst="rect">
-            <a:avLst/>
-          </a:prstGeom>
-          <a:noFill/>
-        </p:spPr>
-        <p:txBody>
-          <a:bodyPr wrap="square" anchor="ctr">
-            <a:spAutoFit/>
-          </a:bodyPr>
-          <a:lstStyle/>
-          <a:p>
-            <a:pPr algn="l">
-              <a:spcAft>
-                <a:spcPts val="0"/>
-              </a:spcAft>
-            </a:pPr>
-            <a:r>
-              <a:rPr sz="1600" b="1">
+              <a:rPr sz="1170" b="0">
                 <a:solidFill>
                   <a:srgbClr val="1A232F"/>
                 </a:solidFill>
                 <a:latin typeface="Apple SD Gothic Neo"/>
               </a:rPr>
-              <a:t>× 모든 데이터에서 SOTA
-× OOF mode-stability가 Final에서 실행됨
-× 모든 executor가 항상 유효
-× 미래 cohort 성능 보장</a:t>
+              <a:t>5-seed 안정성
+표본 5개라 양측 exact
+최소 p=.0625
+모든 모델 대비 분산 우위
+개별 비교는 신호가 있으나
+8모델 Holm 보정 후 비유의
+미래 cohort 일반화
+retrospective 9-setting으로는 불가</a:t>
             </a:r>
           </a:p>
         </p:txBody>
@@ -6900,6 +7401,436 @@
 </file>
 
 <file path=ppt/slides/slide17.xml><?xml version="1.0" encoding="utf-8"?>
+<p:sld xmlns:a="http://schemas.openxmlformats.org/drawingml/2006/main" xmlns:p="http://schemas.openxmlformats.org/presentationml/2006/main" xmlns:r="http://schemas.openxmlformats.org/officeDocument/2006/relationships">
+  <p:cSld>
+    <p:bg>
+      <p:bgPr>
+        <a:solidFill>
+          <a:srgbClr val="FFFFFF"/>
+        </a:solidFill>
+        <a:effectLst/>
+      </p:bgPr>
+    </p:bg>
+    <p:spTree>
+      <p:nvGrpSpPr>
+        <p:cNvPr id="1" name=""/>
+        <p:cNvGrpSpPr/>
+        <p:nvPr/>
+      </p:nvGrpSpPr>
+      <p:grpSpPr/>
+      <p:sp>
+        <p:nvSpPr>
+          <p:cNvPr id="2" name="TextBox 1"/>
+          <p:cNvSpPr txBox="1"/>
+          <p:nvPr/>
+        </p:nvSpPr>
+        <p:spPr>
+          <a:xfrm>
+            <a:off x="502920" y="228600"/>
+            <a:ext cx="10789920" cy="411480"/>
+          </a:xfrm>
+          <a:prstGeom prst="rect">
+            <a:avLst/>
+          </a:prstGeom>
+          <a:noFill/>
+        </p:spPr>
+        <p:txBody>
+          <a:bodyPr wrap="square" anchor="ctr">
+            <a:spAutoFit/>
+          </a:bodyPr>
+          <a:lstStyle/>
+          <a:p>
+            <a:pPr algn="l">
+              <a:spcAft>
+                <a:spcPts val="0"/>
+              </a:spcAft>
+            </a:pPr>
+            <a:r>
+              <a:rPr sz="2500" b="1">
+                <a:solidFill>
+                  <a:srgbClr val="1A232F"/>
+                </a:solidFill>
+                <a:latin typeface="Apple SD Gothic Neo"/>
+              </a:rPr>
+              <a:t>무엇을 주장하고, 무엇을 주장하지 않는가</a:t>
+            </a:r>
+          </a:p>
+        </p:txBody>
+      </p:sp>
+      <p:sp>
+        <p:nvSpPr>
+          <p:cNvPr id="3" name="TextBox 2"/>
+          <p:cNvSpPr txBox="1"/>
+          <p:nvPr/>
+        </p:nvSpPr>
+        <p:spPr>
+          <a:xfrm>
+            <a:off x="530352" y="658368"/>
+            <a:ext cx="10698480" cy="256032"/>
+          </a:xfrm>
+          <a:prstGeom prst="rect">
+            <a:avLst/>
+          </a:prstGeom>
+          <a:noFill/>
+        </p:spPr>
+        <p:txBody>
+          <a:bodyPr wrap="square" anchor="ctr">
+            <a:spAutoFit/>
+          </a:bodyPr>
+          <a:lstStyle/>
+          <a:p>
+            <a:pPr algn="l">
+              <a:spcAft>
+                <a:spcPts val="0"/>
+              </a:spcAft>
+            </a:pPr>
+            <a:r>
+              <a:rPr sz="1050" b="0">
+                <a:solidFill>
+                  <a:srgbClr val="5B6777"/>
+                </a:solidFill>
+                <a:latin typeface="Apple SD Gothic Neo"/>
+              </a:rPr>
+              <a:t>성과보다 실행 계약의 범위를 먼저 고정한다.</a:t>
+            </a:r>
+          </a:p>
+        </p:txBody>
+      </p:sp>
+      <p:sp>
+        <p:nvSpPr>
+          <p:cNvPr id="4" name="TextBox 3"/>
+          <p:cNvSpPr txBox="1"/>
+          <p:nvPr/>
+        </p:nvSpPr>
+        <p:spPr>
+          <a:xfrm>
+            <a:off x="11201400" y="292608"/>
+            <a:ext cx="457200" cy="274320"/>
+          </a:xfrm>
+          <a:prstGeom prst="rect">
+            <a:avLst/>
+          </a:prstGeom>
+          <a:noFill/>
+        </p:spPr>
+        <p:txBody>
+          <a:bodyPr wrap="square" anchor="ctr">
+            <a:spAutoFit/>
+          </a:bodyPr>
+          <a:lstStyle/>
+          <a:p>
+            <a:pPr algn="r">
+              <a:spcAft>
+                <a:spcPts val="0"/>
+              </a:spcAft>
+            </a:pPr>
+            <a:r>
+              <a:rPr sz="1000" b="1">
+                <a:solidFill>
+                  <a:srgbClr val="5B6777"/>
+                </a:solidFill>
+                <a:latin typeface="Apple SD Gothic Neo"/>
+              </a:rPr>
+              <a:t>17</a:t>
+            </a:r>
+          </a:p>
+        </p:txBody>
+      </p:sp>
+      <p:cxnSp>
+        <p:nvCxnSpPr>
+          <p:cNvPr id="5" name="Connector 4"/>
+          <p:cNvCxnSpPr/>
+          <p:nvPr/>
+        </p:nvCxnSpPr>
+        <p:spPr>
+          <a:xfrm>
+            <a:off x="502920" y="987552"/>
+            <a:ext cx="11183112" cy="0"/>
+          </a:xfrm>
+          <a:prstGeom prst="line">
+            <a:avLst/>
+          </a:prstGeom>
+          <a:ln w="12700">
+            <a:solidFill>
+              <a:srgbClr val="DFE3E8"/>
+            </a:solidFill>
+          </a:ln>
+        </p:spPr>
+        <p:style>
+          <a:lnRef idx="2">
+            <a:schemeClr val="accent1"/>
+          </a:lnRef>
+          <a:fillRef idx="0">
+            <a:schemeClr val="accent1"/>
+          </a:fillRef>
+          <a:effectRef idx="1">
+            <a:schemeClr val="accent1"/>
+          </a:effectRef>
+          <a:fontRef idx="minor">
+            <a:schemeClr val="tx1"/>
+          </a:fontRef>
+        </p:style>
+      </p:cxnSp>
+      <p:sp>
+        <p:nvSpPr>
+          <p:cNvPr id="6" name="Rounded Rectangle 5"/>
+          <p:cNvSpPr/>
+          <p:nvPr/>
+        </p:nvSpPr>
+        <p:spPr>
+          <a:xfrm>
+            <a:off x="658368" y="1325880"/>
+            <a:ext cx="5257800" cy="4434840"/>
+          </a:xfrm>
+          <a:prstGeom prst="roundRect">
+            <a:avLst/>
+          </a:prstGeom>
+          <a:solidFill>
+            <a:srgbClr val="E7F6EF"/>
+          </a:solidFill>
+          <a:ln w="15240">
+            <a:solidFill>
+              <a:srgbClr val="2D9168"/>
+            </a:solidFill>
+          </a:ln>
+        </p:spPr>
+        <p:style>
+          <a:lnRef idx="1">
+            <a:schemeClr val="accent1"/>
+          </a:lnRef>
+          <a:fillRef idx="3">
+            <a:schemeClr val="accent1"/>
+          </a:fillRef>
+          <a:effectRef idx="2">
+            <a:schemeClr val="accent1"/>
+          </a:effectRef>
+          <a:fontRef idx="minor">
+            <a:schemeClr val="lt1"/>
+          </a:fontRef>
+        </p:style>
+        <p:txBody>
+          <a:bodyPr rtlCol="0" anchor="ctr"/>
+          <a:lstStyle/>
+          <a:p>
+            <a:pPr algn="ctr"/>
+          </a:p>
+        </p:txBody>
+      </p:sp>
+      <p:sp>
+        <p:nvSpPr>
+          <p:cNvPr id="7" name="TextBox 6"/>
+          <p:cNvSpPr txBox="1"/>
+          <p:nvPr/>
+        </p:nvSpPr>
+        <p:spPr>
+          <a:xfrm>
+            <a:off x="960120" y="1600200"/>
+            <a:ext cx="4663440" cy="411480"/>
+          </a:xfrm>
+          <a:prstGeom prst="rect">
+            <a:avLst/>
+          </a:prstGeom>
+          <a:noFill/>
+        </p:spPr>
+        <p:txBody>
+          <a:bodyPr wrap="square" anchor="ctr">
+            <a:spAutoFit/>
+          </a:bodyPr>
+          <a:lstStyle/>
+          <a:p>
+            <a:pPr algn="l">
+              <a:spcAft>
+                <a:spcPts val="0"/>
+              </a:spcAft>
+            </a:pPr>
+            <a:r>
+              <a:rPr sz="2100" b="1">
+                <a:solidFill>
+                  <a:srgbClr val="2D9168"/>
+                </a:solidFill>
+                <a:latin typeface="Apple SD Gothic Neo"/>
+              </a:rPr>
+              <a:t>말할 수 있음</a:t>
+            </a:r>
+          </a:p>
+        </p:txBody>
+      </p:sp>
+      <p:sp>
+        <p:nvSpPr>
+          <p:cNvPr id="8" name="TextBox 7"/>
+          <p:cNvSpPr txBox="1"/>
+          <p:nvPr/>
+        </p:nvSpPr>
+        <p:spPr>
+          <a:xfrm>
+            <a:off x="960120" y="2304288"/>
+            <a:ext cx="4617720" cy="2560320"/>
+          </a:xfrm>
+          <a:prstGeom prst="rect">
+            <a:avLst/>
+          </a:prstGeom>
+          <a:noFill/>
+        </p:spPr>
+        <p:txBody>
+          <a:bodyPr wrap="square" anchor="ctr">
+            <a:spAutoFit/>
+          </a:bodyPr>
+          <a:lstStyle/>
+          <a:p>
+            <a:pPr algn="l">
+              <a:spcAft>
+                <a:spcPts val="0"/>
+              </a:spcAft>
+            </a:pPr>
+            <a:r>
+              <a:rPr sz="1600" b="1">
+                <a:solidFill>
+                  <a:srgbClr val="1A232F"/>
+                </a:solidFill>
+                <a:latin typeface="Apple SD Gothic Neo"/>
+              </a:rPr>
+              <a:t>✓ 9-setting summary gain
+✓ prior–residual 역할 분리
+✓ executor 효과의 반례
+✓ test 전 route 동결</a:t>
+            </a:r>
+          </a:p>
+        </p:txBody>
+      </p:sp>
+      <p:sp>
+        <p:nvSpPr>
+          <p:cNvPr id="9" name="Rounded Rectangle 8"/>
+          <p:cNvSpPr/>
+          <p:nvPr/>
+        </p:nvSpPr>
+        <p:spPr>
+          <a:xfrm>
+            <a:off x="6272784" y="1325880"/>
+            <a:ext cx="5257800" cy="4434840"/>
+          </a:xfrm>
+          <a:prstGeom prst="roundRect">
+            <a:avLst/>
+          </a:prstGeom>
+          <a:solidFill>
+            <a:srgbClr val="FBEBEB"/>
+          </a:solidFill>
+          <a:ln w="15240">
+            <a:solidFill>
+              <a:srgbClr val="BE4141"/>
+            </a:solidFill>
+          </a:ln>
+        </p:spPr>
+        <p:style>
+          <a:lnRef idx="1">
+            <a:schemeClr val="accent1"/>
+          </a:lnRef>
+          <a:fillRef idx="3">
+            <a:schemeClr val="accent1"/>
+          </a:fillRef>
+          <a:effectRef idx="2">
+            <a:schemeClr val="accent1"/>
+          </a:effectRef>
+          <a:fontRef idx="minor">
+            <a:schemeClr val="lt1"/>
+          </a:fontRef>
+        </p:style>
+        <p:txBody>
+          <a:bodyPr rtlCol="0" anchor="ctr"/>
+          <a:lstStyle/>
+          <a:p>
+            <a:pPr algn="ctr"/>
+          </a:p>
+        </p:txBody>
+      </p:sp>
+      <p:sp>
+        <p:nvSpPr>
+          <p:cNvPr id="10" name="TextBox 9"/>
+          <p:cNvSpPr txBox="1"/>
+          <p:nvPr/>
+        </p:nvSpPr>
+        <p:spPr>
+          <a:xfrm>
+            <a:off x="6574536" y="1600200"/>
+            <a:ext cx="4663440" cy="411480"/>
+          </a:xfrm>
+          <a:prstGeom prst="rect">
+            <a:avLst/>
+          </a:prstGeom>
+          <a:noFill/>
+        </p:spPr>
+        <p:txBody>
+          <a:bodyPr wrap="square" anchor="ctr">
+            <a:spAutoFit/>
+          </a:bodyPr>
+          <a:lstStyle/>
+          <a:p>
+            <a:pPr algn="l">
+              <a:spcAft>
+                <a:spcPts val="0"/>
+              </a:spcAft>
+            </a:pPr>
+            <a:r>
+              <a:rPr sz="2100" b="1">
+                <a:solidFill>
+                  <a:srgbClr val="BE4141"/>
+                </a:solidFill>
+                <a:latin typeface="Apple SD Gothic Neo"/>
+              </a:rPr>
+              <a:t>말하면 안 됨</a:t>
+            </a:r>
+          </a:p>
+        </p:txBody>
+      </p:sp>
+      <p:sp>
+        <p:nvSpPr>
+          <p:cNvPr id="11" name="TextBox 10"/>
+          <p:cNvSpPr txBox="1"/>
+          <p:nvPr/>
+        </p:nvSpPr>
+        <p:spPr>
+          <a:xfrm>
+            <a:off x="6574536" y="2304288"/>
+            <a:ext cx="4617720" cy="2560320"/>
+          </a:xfrm>
+          <a:prstGeom prst="rect">
+            <a:avLst/>
+          </a:prstGeom>
+          <a:noFill/>
+        </p:spPr>
+        <p:txBody>
+          <a:bodyPr wrap="square" anchor="ctr">
+            <a:spAutoFit/>
+          </a:bodyPr>
+          <a:lstStyle/>
+          <a:p>
+            <a:pPr algn="l">
+              <a:spcAft>
+                <a:spcPts val="0"/>
+              </a:spcAft>
+            </a:pPr>
+            <a:r>
+              <a:rPr sz="1600" b="1">
+                <a:solidFill>
+                  <a:srgbClr val="1A232F"/>
+                </a:solidFill>
+                <a:latin typeface="Apple SD Gothic Neo"/>
+              </a:rPr>
+              <a:t>× 모든 데이터에서 SOTA
+× OOF mode-stability가 Final에서 실행됨
+× 모든 executor가 항상 유효
+× 미래 cohort 성능 보장</a:t>
+            </a:r>
+          </a:p>
+        </p:txBody>
+      </p:sp>
+    </p:spTree>
+  </p:cSld>
+  <p:clrMapOvr>
+    <a:masterClrMapping/>
+  </p:clrMapOvr>
+</p:sld>
+</file>
+
+<file path=ppt/slides/slide18.xml><?xml version="1.0" encoding="utf-8"?>
 <p:sld xmlns:a="http://schemas.openxmlformats.org/drawingml/2006/main" xmlns:p="http://schemas.openxmlformats.org/presentationml/2006/main" xmlns:r="http://schemas.openxmlformats.org/officeDocument/2006/relationships">
   <p:cSld>
     <p:bg>
@@ -7828,7 +8759,7 @@
                 </a:solidFill>
                 <a:latin typeface="Apple SD Gothic Neo"/>
               </a:rPr>
-              <a:t>17 / 17</a:t>
+              <a:t>18 / 18</a:t>
             </a:r>
           </a:p>
         </p:txBody>

</xml_diff>

<commit_message>
Mark ablation decisions as matching Final routes
Co-authored-by: Cursor <cursoragent@cursor.com>
</commit_message>
<xml_diff>
--- a/ppt/PP-X_Final_Visual_Talk_20min.pptx
+++ b/ppt/PP-X_Final_Visual_Talk_20min.pptx
@@ -4722,7 +4722,7 @@
                 </a:solidFill>
                 <a:latin typeface="Apple SD Gothic Neo"/>
               </a:rPr>
-              <a:t>켜야 하는 경우</a:t>
+              <a:t>Ablation → Final ON</a:t>
             </a:r>
           </a:p>
         </p:txBody>
@@ -4761,8 +4761,8 @@
                 </a:solidFill>
                 <a:latin typeface="Apple SD Gothic Neo"/>
               </a:rPr>
-              <a:t>HUST transport
-MICH dual-scale</a:t>
+              <a:t>MICH dual-scale
+.468 → .751</a:t>
             </a:r>
           </a:p>
         </p:txBody>
@@ -4846,7 +4846,7 @@
                 </a:solidFill>
                 <a:latin typeface="Apple SD Gothic Neo"/>
               </a:rPr>
-              <a:t>끄는 반례</a:t>
+              <a:t>Ablation → Final OFF</a:t>
             </a:r>
           </a:p>
         </p:txBody>
@@ -4886,7 +4886,7 @@
                 <a:latin typeface="Apple SD Gothic Neo"/>
               </a:rPr>
               <a:t>RWTH dual-scale
-MICH fixed bound</a:t>
+.878 → .842</a:t>
             </a:r>
           </a:p>
         </p:txBody>
@@ -4927,6 +4927,90 @@
               </a:rPr>
               <a:t>그래서 contract + Val
 승인이 필요하다.</a:t>
+            </a:r>
+          </a:p>
+        </p:txBody>
+      </p:sp>
+      <p:sp>
+        <p:nvSpPr>
+          <p:cNvPr id="14" name="Rounded Rectangle 13"/>
+          <p:cNvSpPr/>
+          <p:nvPr/>
+        </p:nvSpPr>
+        <p:spPr>
+          <a:xfrm>
+            <a:off x="868680" y="5806440"/>
+            <a:ext cx="10652760" cy="438912"/>
+          </a:xfrm>
+          <a:prstGeom prst="roundRect">
+            <a:avLst/>
+          </a:prstGeom>
+          <a:solidFill>
+            <a:srgbClr val="E9F3FB"/>
+          </a:solidFill>
+          <a:ln w="15240">
+            <a:solidFill>
+              <a:srgbClr val="1F6BB5"/>
+            </a:solidFill>
+          </a:ln>
+        </p:spPr>
+        <p:style>
+          <a:lnRef idx="1">
+            <a:schemeClr val="accent1"/>
+          </a:lnRef>
+          <a:fillRef idx="3">
+            <a:schemeClr val="accent1"/>
+          </a:fillRef>
+          <a:effectRef idx="2">
+            <a:schemeClr val="accent1"/>
+          </a:effectRef>
+          <a:fontRef idx="minor">
+            <a:schemeClr val="lt1"/>
+          </a:fontRef>
+        </p:style>
+        <p:txBody>
+          <a:bodyPr rtlCol="0" anchor="ctr"/>
+          <a:lstStyle/>
+          <a:p>
+            <a:pPr algn="ctr"/>
+          </a:p>
+        </p:txBody>
+      </p:sp>
+      <p:sp>
+        <p:nvSpPr>
+          <p:cNvPr id="15" name="TextBox 14"/>
+          <p:cNvSpPr txBox="1"/>
+          <p:nvPr/>
+        </p:nvSpPr>
+        <p:spPr>
+          <a:xfrm>
+            <a:off x="1051560" y="5843016"/>
+            <a:ext cx="10287000" cy="347472"/>
+          </a:xfrm>
+          <a:prstGeom prst="rect">
+            <a:avLst/>
+          </a:prstGeom>
+          <a:noFill/>
+        </p:spPr>
+        <p:txBody>
+          <a:bodyPr wrap="square" anchor="ctr">
+            <a:spAutoFit/>
+          </a:bodyPr>
+          <a:lstStyle/>
+          <a:p>
+            <a:pPr algn="ctr">
+              <a:spcAft>
+                <a:spcPts val="0"/>
+              </a:spcAft>
+            </a:pPr>
+            <a:r>
+              <a:rPr sz="1150" b="1">
+                <a:solidFill>
+                  <a:srgbClr val="1F6BB5"/>
+                </a:solidFill>
+                <a:latin typeface="Apple SD Gothic Neo"/>
+              </a:rPr>
+              <a:t>강제 ON/OFF ablation의 방향과 실제 Final route가 일치: MICH는 dual ON, RWTH는 dual OFF(fixed bound).</a:t>
             </a:r>
           </a:p>
         </p:txBody>
@@ -7248,16 +7332,16 @@
               <a:t>질문
 각 optional module을 왜 켜거나 끄나?
 방법
-같은 prior family 안에서 on vs off
+Final 선택 전 강제 on/off ablation
 physical-unit 효과 · 24개 BH 보정
-도움
+도움 → 실제 Final ON
 MICH dual: .468→.751 (q=.031)
 HUST·MATR-b2 transport 유의
-해로움
+해로움 → 실제 Final OFF
 RWTH dual: .878→.842 (q=.021)
-MICH fixed bound도 유의하게 악화
+RWTH Final은 fixed bound .878
 결론
-모든 module을 항상 켜면 안 됨</a:t>
+ablation 방향과 Final route가 일치</a:t>
             </a:r>
           </a:p>
         </p:txBody>

</xml_diff>